<commit_message>
Updated student 2 name and modified slides
Trim redundant slide, relocate Amdahl's-law point on presentation deck

- Remove slide 11 ("Why the speed-up is 4.7x and not 8x") — its physical
  cores/SMT and thread-placement points duplicated slides 5 and 7
- Move its one new point (sequential compaction / Amdahl's law) into
  slide 6, next to the 0.97x-at-1-thread data point it explains
- Slide count: 15 → 14; slides 1-5, 7-10, 12 unchanged
</commit_message>
<xml_diff>
--- a/FIT3143_Lab1_Presentation.pptx
+++ b/FIT3143_Lab1_Presentation.pptx
@@ -15,7 +15,6 @@
     <p:sldId id="263" r:id="rId9"/>
     <p:sldId id="264" r:id="rId10"/>
     <p:sldId id="265" r:id="rId11"/>
-    <p:sldId id="266" r:id="rId12"/>
     <p:sldId id="267" r:id="rId13"/>
     <p:sldId id="268" r:id="rId14"/>
     <p:sldId id="269" r:id="rId15"/>
@@ -628,94 +627,6 @@
             <a:fld id="{F7021451-1387-4CA6-816F-3879F97B5CBC}" type="slidenum">
               <a:rPr lang="en-US"/>
               <a:t>10</a:t>
-            </a:fld>
-            <a:endParaRPr lang="en-US"/>
-          </a:p>
-        </p:txBody>
-      </p:sp>
-    </p:spTree>
-    <p:extLst>
-      <p:ext uri="{BB962C8B-B14F-4D97-AF65-F5344CB8AC3E}">
-        <p14:creationId xmlns:p14="http://schemas.microsoft.com/office/powerpoint/2010/main" val="1024086991"/>
-      </p:ext>
-    </p:extLst>
-  </p:cSld>
-  <p:clrMapOvr>
-    <a:masterClrMapping/>
-  </p:clrMapOvr>
-</p:notes>
-</file>
-
-<file path=ppt/notesSlides/notesSlide11.xml><?xml version="1.0" encoding="utf-8"?>
-<p:notes xmlns:a="http://schemas.openxmlformats.org/drawingml/2006/main" xmlns:r="http://schemas.openxmlformats.org/officeDocument/2006/relationships" xmlns:p="http://schemas.openxmlformats.org/presentationml/2006/main">
-  <p:cSld>
-    <p:spTree>
-      <p:nvGrpSpPr>
-        <p:cNvPr id="1" name=""/>
-        <p:cNvGrpSpPr/>
-        <p:nvPr/>
-      </p:nvGrpSpPr>
-      <p:grpSpPr>
-        <a:xfrm>
-          <a:off x="0" y="0"/>
-          <a:ext cx="0" cy="0"/>
-          <a:chOff x="0" y="0"/>
-          <a:chExt cx="0" cy="0"/>
-        </a:xfrm>
-      </p:grpSpPr>
-      <p:sp>
-        <p:nvSpPr>
-          <p:cNvPr id="2" name="Slide Image Placeholder 1"/>
-          <p:cNvSpPr>
-            <a:spLocks noGrp="1" noRot="1" noChangeAspect="1"/>
-          </p:cNvSpPr>
-          <p:nvPr>
-            <p:ph type="sldImg"/>
-          </p:nvPr>
-        </p:nvSpPr>
-        <p:spPr/>
-      </p:sp>
-      <p:sp>
-        <p:nvSpPr>
-          <p:cNvPr id="3" name="Notes Placeholder 2"/>
-          <p:cNvSpPr>
-            <a:spLocks noGrp="1"/>
-          </p:cNvSpPr>
-          <p:nvPr>
-            <p:ph type="body" idx="1"/>
-          </p:nvPr>
-        </p:nvSpPr>
-        <p:spPr/>
-        <p:txBody>
-          <a:bodyPr/>
-          <a:lstStyle/>
-          <a:p>
-            <a:r>
-              <a:rPr lang="en-US" dirty="0"/>
-              <a:t>This is the answer to the standard Q&amp;A question. Give reasons 1 and 2 at minimum.</a:t>
-            </a:r>
-            <a:endParaRPr lang="en-US" dirty="0"/>
-          </a:p>
-        </p:txBody>
-      </p:sp>
-      <p:sp>
-        <p:nvSpPr>
-          <p:cNvPr id="4" name="Slide Number Placeholder 3"/>
-          <p:cNvSpPr>
-            <a:spLocks noGrp="1"/>
-          </p:cNvSpPr>
-          <p:nvPr>
-            <p:ph type="sldNum" sz="quarter" idx="10"/>
-          </p:nvPr>
-        </p:nvSpPr>
-        <p:spPr/>
-        <p:txBody>
-          <a:bodyPr/>
-          <a:lstStyle/>
-          <a:p>
-            <a:fld id="{F7021451-1387-4CA6-816F-3879F97B5CBC}" type="slidenum">
-              <a:rPr lang="en-US"/>
-              <a:t>11</a:t>
             </a:fld>
             <a:endParaRPr lang="en-US"/>
           </a:p>
@@ -2580,579 +2491,6 @@
 </p:sld>
 </file>
 
-<file path=ppt/slides/slide11.xml><?xml version="1.0" encoding="utf-8"?>
-<p:sld xmlns:a="http://schemas.openxmlformats.org/drawingml/2006/main" xmlns:r="http://schemas.openxmlformats.org/officeDocument/2006/relationships" xmlns:p="http://schemas.openxmlformats.org/presentationml/2006/main">
-  <p:cSld name="Slide 11">
-    <p:spTree>
-      <p:nvGrpSpPr>
-        <p:cNvPr id="1" name=""/>
-        <p:cNvGrpSpPr/>
-        <p:nvPr/>
-      </p:nvGrpSpPr>
-      <p:grpSpPr>
-        <a:xfrm>
-          <a:off x="0" y="0"/>
-          <a:ext cx="0" cy="0"/>
-          <a:chOff x="0" y="0"/>
-          <a:chExt cx="0" cy="0"/>
-        </a:xfrm>
-      </p:grpSpPr>
-      <p:sp>
-        <p:nvSpPr>
-          <p:cNvPr id="2" name="Shape 0"/>
-          <p:cNvSpPr/>
-          <p:nvPr/>
-        </p:nvSpPr>
-        <p:spPr>
-          <a:xfrm>
-            <a:off x="548640" y="384048"/>
-            <a:ext cx="566928" cy="566928"/>
-          </a:xfrm>
-          <a:prstGeom prst="ellipse">
-            <a:avLst/>
-          </a:prstGeom>
-          <a:solidFill>
-            <a:srgbClr val="EB6834"/>
-          </a:solidFill>
-          <a:ln/>
-        </p:spPr>
-      </p:sp>
-      <p:sp>
-        <p:nvSpPr>
-          <p:cNvPr id="3" name="Text 1"/>
-          <p:cNvSpPr/>
-          <p:nvPr/>
-        </p:nvSpPr>
-        <p:spPr>
-          <a:xfrm>
-            <a:off x="548640" y="384048"/>
-            <a:ext cx="566928" cy="566928"/>
-          </a:xfrm>
-          <a:prstGeom prst="rect">
-            <a:avLst/>
-          </a:prstGeom>
-          <a:noFill/>
-          <a:ln/>
-        </p:spPr>
-        <p:txBody>
-          <a:bodyPr wrap="square" lIns="0" tIns="0" rIns="0" bIns="0" rtlCol="0" anchor="ctr"/>
-          <a:lstStyle/>
-          <a:p>
-            <a:pPr algn="ctr" indent="0" marL="0">
-              <a:buNone/>
-            </a:pPr>
-            <a:r>
-              <a:rPr lang="en-US" sz="2200" b="1" dirty="0">
-                <a:solidFill>
-                  <a:srgbClr val="FFFFFF"/>
-                </a:solidFill>
-                <a:latin typeface="Calibri" pitchFamily="34" charset="0"/>
-                <a:ea typeface="Calibri" pitchFamily="34" charset="-122"/>
-                <a:cs typeface="Calibri" pitchFamily="34" charset="-120"/>
-              </a:rPr>
-              <a:t>∑</a:t>
-            </a:r>
-            <a:endParaRPr lang="en-US" sz="2200" dirty="0"/>
-          </a:p>
-        </p:txBody>
-      </p:sp>
-      <p:sp>
-        <p:nvSpPr>
-          <p:cNvPr id="4" name="Text 2"/>
-          <p:cNvSpPr/>
-          <p:nvPr/>
-        </p:nvSpPr>
-        <p:spPr>
-          <a:xfrm>
-            <a:off x="1325880" y="347472"/>
-            <a:ext cx="10287000" cy="457200"/>
-          </a:xfrm>
-          <a:prstGeom prst="rect">
-            <a:avLst/>
-          </a:prstGeom>
-          <a:noFill/>
-          <a:ln/>
-        </p:spPr>
-        <p:txBody>
-          <a:bodyPr wrap="square" lIns="0" tIns="0" rIns="0" bIns="0" rtlCol="0" anchor="ctr"/>
-          <a:lstStyle/>
-          <a:p>
-            <a:pPr indent="0" marL="0">
-              <a:buNone/>
-            </a:pPr>
-            <a:r>
-              <a:rPr lang="en-US" sz="3000" b="1" dirty="0">
-                <a:solidFill>
-                  <a:srgbClr val="1A2226"/>
-                </a:solidFill>
-                <a:latin typeface="Calibri" pitchFamily="34" charset="0"/>
-                <a:ea typeface="Calibri" pitchFamily="34" charset="-122"/>
-                <a:cs typeface="Calibri" pitchFamily="34" charset="-120"/>
-              </a:rPr>
-              <a:t>Why the speed-up is 4.7× and not 8×</a:t>
-            </a:r>
-            <a:endParaRPr lang="en-US" sz="3000" dirty="0"/>
-          </a:p>
-        </p:txBody>
-      </p:sp>
-      <p:sp>
-        <p:nvSpPr>
-          <p:cNvPr id="5" name="Text 3"/>
-          <p:cNvSpPr/>
-          <p:nvPr/>
-        </p:nvSpPr>
-        <p:spPr>
-          <a:xfrm>
-            <a:off x="1325880" y="804672"/>
-            <a:ext cx="10287000" cy="310896"/>
-          </a:xfrm>
-          <a:prstGeom prst="rect">
-            <a:avLst/>
-          </a:prstGeom>
-          <a:noFill/>
-          <a:ln/>
-        </p:spPr>
-        <p:txBody>
-          <a:bodyPr wrap="square" lIns="0" tIns="0" rIns="0" bIns="0" rtlCol="0" anchor="ctr"/>
-          <a:lstStyle/>
-          <a:p>
-            <a:pPr indent="0" marL="0">
-              <a:buNone/>
-            </a:pPr>
-            <a:r>
-              <a:rPr lang="en-US" sz="1300" dirty="0">
-                <a:solidFill>
-                  <a:srgbClr val="52616B"/>
-                </a:solidFill>
-                <a:latin typeface="Calibri" pitchFamily="34" charset="0"/>
-                <a:ea typeface="Calibri" pitchFamily="34" charset="-122"/>
-                <a:cs typeface="Calibri" pitchFamily="34" charset="-120"/>
-              </a:rPr>
-              <a:t>Three effects, each measured rather than assumed</a:t>
-            </a:r>
-            <a:endParaRPr lang="en-US" sz="1300" dirty="0"/>
-          </a:p>
-        </p:txBody>
-      </p:sp>
-      <p:sp>
-        <p:nvSpPr>
-          <p:cNvPr id="6" name="Shape 4"/>
-          <p:cNvSpPr/>
-          <p:nvPr/>
-        </p:nvSpPr>
-        <p:spPr>
-          <a:xfrm>
-            <a:off x="548640" y="1472184"/>
-            <a:ext cx="457200" cy="457200"/>
-          </a:xfrm>
-          <a:prstGeom prst="ellipse">
-            <a:avLst/>
-          </a:prstGeom>
-          <a:solidFill>
-            <a:srgbClr val="EB6834"/>
-          </a:solidFill>
-          <a:ln/>
-        </p:spPr>
-      </p:sp>
-      <p:sp>
-        <p:nvSpPr>
-          <p:cNvPr id="7" name="Text 5"/>
-          <p:cNvSpPr/>
-          <p:nvPr/>
-        </p:nvSpPr>
-        <p:spPr>
-          <a:xfrm>
-            <a:off x="548640" y="1472184"/>
-            <a:ext cx="457200" cy="457200"/>
-          </a:xfrm>
-          <a:prstGeom prst="rect">
-            <a:avLst/>
-          </a:prstGeom>
-          <a:noFill/>
-          <a:ln/>
-        </p:spPr>
-        <p:txBody>
-          <a:bodyPr wrap="square" lIns="0" tIns="0" rIns="0" bIns="0" rtlCol="0" anchor="ctr"/>
-          <a:lstStyle/>
-          <a:p>
-            <a:pPr algn="ctr" indent="0" marL="0">
-              <a:buNone/>
-            </a:pPr>
-            <a:r>
-              <a:rPr lang="en-US" sz="1700" b="1" dirty="0">
-                <a:solidFill>
-                  <a:srgbClr val="FFFFFF"/>
-                </a:solidFill>
-                <a:latin typeface="Calibri" pitchFamily="34" charset="0"/>
-                <a:ea typeface="Calibri" pitchFamily="34" charset="-122"/>
-                <a:cs typeface="Calibri" pitchFamily="34" charset="-120"/>
-              </a:rPr>
-              <a:t>1</a:t>
-            </a:r>
-            <a:endParaRPr lang="en-US" sz="1700" dirty="0"/>
-          </a:p>
-        </p:txBody>
-      </p:sp>
-      <p:sp>
-        <p:nvSpPr>
-          <p:cNvPr id="8" name="Text 6"/>
-          <p:cNvSpPr/>
-          <p:nvPr/>
-        </p:nvSpPr>
-        <p:spPr>
-          <a:xfrm>
-            <a:off x="1234440" y="1417320"/>
-            <a:ext cx="10241280" cy="365760"/>
-          </a:xfrm>
-          <a:prstGeom prst="rect">
-            <a:avLst/>
-          </a:prstGeom>
-          <a:noFill/>
-          <a:ln/>
-        </p:spPr>
-        <p:txBody>
-          <a:bodyPr wrap="square" lIns="0" tIns="0" rIns="0" bIns="0" rtlCol="0" anchor="ctr"/>
-          <a:lstStyle/>
-          <a:p>
-            <a:pPr indent="0" marL="0">
-              <a:buNone/>
-            </a:pPr>
-            <a:r>
-              <a:rPr lang="en-US" sz="1700" b="1" dirty="0">
-                <a:solidFill>
-                  <a:srgbClr val="1A2226"/>
-                </a:solidFill>
-                <a:latin typeface="Calibri" pitchFamily="34" charset="0"/>
-                <a:ea typeface="Calibri" pitchFamily="34" charset="-122"/>
-                <a:cs typeface="Calibri" pitchFamily="34" charset="-120"/>
-              </a:rPr>
-              <a:t>Only four physical cores</a:t>
-            </a:r>
-            <a:endParaRPr lang="en-US" sz="1700" dirty="0"/>
-          </a:p>
-        </p:txBody>
-      </p:sp>
-      <p:sp>
-        <p:nvSpPr>
-          <p:cNvPr id="9" name="Text 7"/>
-          <p:cNvSpPr/>
-          <p:nvPr/>
-        </p:nvSpPr>
-        <p:spPr>
-          <a:xfrm>
-            <a:off x="1234440" y="1801368"/>
-            <a:ext cx="10241280" cy="868680"/>
-          </a:xfrm>
-          <a:prstGeom prst="rect">
-            <a:avLst/>
-          </a:prstGeom>
-          <a:noFill/>
-          <a:ln/>
-        </p:spPr>
-        <p:txBody>
-          <a:bodyPr wrap="square" lIns="0" tIns="0" rIns="0" bIns="0" rtlCol="0" anchor="t"/>
-          <a:lstStyle/>
-          <a:p>
-            <a:pPr indent="0" marL="0">
-              <a:buNone/>
-            </a:pPr>
-            <a:r>
-              <a:rPr lang="en-US" sz="1300" dirty="0">
-                <a:solidFill>
-                  <a:srgbClr val="52616B"/>
-                </a:solidFill>
-                <a:latin typeface="Calibri" pitchFamily="34" charset="0"/>
-                <a:ea typeface="Calibri" pitchFamily="34" charset="-122"/>
-                <a:cs typeface="Calibri" pitchFamily="34" charset="-120"/>
-              </a:rPr>
-              <a:t>The other four logical CPUs are SMT siblings sharing one core's execution units — above all the integer divider that is_prime hammers. SMT adds roughly 20% on top of 4×, not another 4×.</a:t>
-            </a:r>
-            <a:endParaRPr lang="en-US" sz="1300" dirty="0"/>
-          </a:p>
-        </p:txBody>
-      </p:sp>
-      <p:sp>
-        <p:nvSpPr>
-          <p:cNvPr id="10" name="Shape 8"/>
-          <p:cNvSpPr/>
-          <p:nvPr/>
-        </p:nvSpPr>
-        <p:spPr>
-          <a:xfrm>
-            <a:off x="548640" y="2953512"/>
-            <a:ext cx="457200" cy="457200"/>
-          </a:xfrm>
-          <a:prstGeom prst="ellipse">
-            <a:avLst/>
-          </a:prstGeom>
-          <a:solidFill>
-            <a:srgbClr val="2A78D6"/>
-          </a:solidFill>
-          <a:ln/>
-        </p:spPr>
-      </p:sp>
-      <p:sp>
-        <p:nvSpPr>
-          <p:cNvPr id="11" name="Text 9"/>
-          <p:cNvSpPr/>
-          <p:nvPr/>
-        </p:nvSpPr>
-        <p:spPr>
-          <a:xfrm>
-            <a:off x="548640" y="2953512"/>
-            <a:ext cx="457200" cy="457200"/>
-          </a:xfrm>
-          <a:prstGeom prst="rect">
-            <a:avLst/>
-          </a:prstGeom>
-          <a:noFill/>
-          <a:ln/>
-        </p:spPr>
-        <p:txBody>
-          <a:bodyPr wrap="square" lIns="0" tIns="0" rIns="0" bIns="0" rtlCol="0" anchor="ctr"/>
-          <a:lstStyle/>
-          <a:p>
-            <a:pPr algn="ctr" indent="0" marL="0">
-              <a:buNone/>
-            </a:pPr>
-            <a:r>
-              <a:rPr lang="en-US" sz="1700" b="1" dirty="0">
-                <a:solidFill>
-                  <a:srgbClr val="FFFFFF"/>
-                </a:solidFill>
-                <a:latin typeface="Calibri" pitchFamily="34" charset="0"/>
-                <a:ea typeface="Calibri" pitchFamily="34" charset="-122"/>
-                <a:cs typeface="Calibri" pitchFamily="34" charset="-120"/>
-              </a:rPr>
-              <a:t>2</a:t>
-            </a:r>
-            <a:endParaRPr lang="en-US" sz="1700" dirty="0"/>
-          </a:p>
-        </p:txBody>
-      </p:sp>
-      <p:sp>
-        <p:nvSpPr>
-          <p:cNvPr id="12" name="Text 10"/>
-          <p:cNvSpPr/>
-          <p:nvPr/>
-        </p:nvSpPr>
-        <p:spPr>
-          <a:xfrm>
-            <a:off x="1234440" y="2898648"/>
-            <a:ext cx="10241280" cy="365760"/>
-          </a:xfrm>
-          <a:prstGeom prst="rect">
-            <a:avLst/>
-          </a:prstGeom>
-          <a:noFill/>
-          <a:ln/>
-        </p:spPr>
-        <p:txBody>
-          <a:bodyPr wrap="square" lIns="0" tIns="0" rIns="0" bIns="0" rtlCol="0" anchor="ctr"/>
-          <a:lstStyle/>
-          <a:p>
-            <a:pPr indent="0" marL="0">
-              <a:buNone/>
-            </a:pPr>
-            <a:r>
-              <a:rPr lang="en-US" sz="1700" b="1" dirty="0">
-                <a:solidFill>
-                  <a:srgbClr val="1A2226"/>
-                </a:solidFill>
-                <a:latin typeface="Calibri" pitchFamily="34" charset="0"/>
-                <a:ea typeface="Calibri" pitchFamily="34" charset="-122"/>
-                <a:cs typeface="Calibri" pitchFamily="34" charset="-120"/>
-              </a:rPr>
-              <a:t>A sequential portion remains</a:t>
-            </a:r>
-            <a:endParaRPr lang="en-US" sz="1700" dirty="0"/>
-          </a:p>
-        </p:txBody>
-      </p:sp>
-      <p:sp>
-        <p:nvSpPr>
-          <p:cNvPr id="13" name="Text 11"/>
-          <p:cNvSpPr/>
-          <p:nvPr/>
-        </p:nvSpPr>
-        <p:spPr>
-          <a:xfrm>
-            <a:off x="1234440" y="3282696"/>
-            <a:ext cx="10241280" cy="868680"/>
-          </a:xfrm>
-          <a:prstGeom prst="rect">
-            <a:avLst/>
-          </a:prstGeom>
-          <a:noFill/>
-          <a:ln/>
-        </p:spPr>
-        <p:txBody>
-          <a:bodyPr wrap="square" lIns="0" tIns="0" rIns="0" bIns="0" rtlCol="0" anchor="t"/>
-          <a:lstStyle/>
-          <a:p>
-            <a:pPr indent="0" marL="0">
-              <a:buNone/>
-            </a:pPr>
-            <a:r>
-              <a:rPr lang="en-US" sz="1300" dirty="0">
-                <a:solidFill>
-                  <a:srgbClr val="52616B"/>
-                </a:solidFill>
-                <a:latin typeface="Calibri" pitchFamily="34" charset="0"/>
-                <a:ea typeface="Calibri" pitchFamily="34" charset="-122"/>
-                <a:cs typeface="Calibri" pitchFamily="34" charset="-120"/>
-              </a:rPr>
-              <a:t>Amdahl's law. The shared results[] array is allocated and compacted into the sorted list by a single thread — an O(n) pass that does not shrink as threads are added. It is also why one thread is slower than the serial program, at 0.97×.</a:t>
-            </a:r>
-            <a:endParaRPr lang="en-US" sz="1300" dirty="0"/>
-          </a:p>
-        </p:txBody>
-      </p:sp>
-      <p:sp>
-        <p:nvSpPr>
-          <p:cNvPr id="14" name="Shape 12"/>
-          <p:cNvSpPr/>
-          <p:nvPr/>
-        </p:nvSpPr>
-        <p:spPr>
-          <a:xfrm>
-            <a:off x="548640" y="4434840"/>
-            <a:ext cx="457200" cy="457200"/>
-          </a:xfrm>
-          <a:prstGeom prst="ellipse">
-            <a:avLst/>
-          </a:prstGeom>
-          <a:solidFill>
-            <a:srgbClr val="1BAF7A"/>
-          </a:solidFill>
-          <a:ln/>
-        </p:spPr>
-      </p:sp>
-      <p:sp>
-        <p:nvSpPr>
-          <p:cNvPr id="15" name="Text 13"/>
-          <p:cNvSpPr/>
-          <p:nvPr/>
-        </p:nvSpPr>
-        <p:spPr>
-          <a:xfrm>
-            <a:off x="548640" y="4434840"/>
-            <a:ext cx="457200" cy="457200"/>
-          </a:xfrm>
-          <a:prstGeom prst="rect">
-            <a:avLst/>
-          </a:prstGeom>
-          <a:noFill/>
-          <a:ln/>
-        </p:spPr>
-        <p:txBody>
-          <a:bodyPr wrap="square" lIns="0" tIns="0" rIns="0" bIns="0" rtlCol="0" anchor="ctr"/>
-          <a:lstStyle/>
-          <a:p>
-            <a:pPr algn="ctr" indent="0" marL="0">
-              <a:buNone/>
-            </a:pPr>
-            <a:r>
-              <a:rPr lang="en-US" sz="1700" b="1" dirty="0">
-                <a:solidFill>
-                  <a:srgbClr val="FFFFFF"/>
-                </a:solidFill>
-                <a:latin typeface="Calibri" pitchFamily="34" charset="0"/>
-                <a:ea typeface="Calibri" pitchFamily="34" charset="-122"/>
-                <a:cs typeface="Calibri" pitchFamily="34" charset="-120"/>
-              </a:rPr>
-              <a:t>3</a:t>
-            </a:r>
-            <a:endParaRPr lang="en-US" sz="1700" dirty="0"/>
-          </a:p>
-        </p:txBody>
-      </p:sp>
-      <p:sp>
-        <p:nvSpPr>
-          <p:cNvPr id="16" name="Text 14"/>
-          <p:cNvSpPr/>
-          <p:nvPr/>
-        </p:nvSpPr>
-        <p:spPr>
-          <a:xfrm>
-            <a:off x="1234440" y="4379976"/>
-            <a:ext cx="10241280" cy="365760"/>
-          </a:xfrm>
-          <a:prstGeom prst="rect">
-            <a:avLst/>
-          </a:prstGeom>
-          <a:noFill/>
-          <a:ln/>
-        </p:spPr>
-        <p:txBody>
-          <a:bodyPr wrap="square" lIns="0" tIns="0" rIns="0" bIns="0" rtlCol="0" anchor="ctr"/>
-          <a:lstStyle/>
-          <a:p>
-            <a:pPr indent="0" marL="0">
-              <a:buNone/>
-            </a:pPr>
-            <a:r>
-              <a:rPr lang="en-US" sz="1700" b="1" dirty="0">
-                <a:solidFill>
-                  <a:srgbClr val="1A2226"/>
-                </a:solidFill>
-                <a:latin typeface="Calibri" pitchFamily="34" charset="0"/>
-                <a:ea typeface="Calibri" pitchFamily="34" charset="-122"/>
-                <a:cs typeface="Calibri" pitchFamily="34" charset="-120"/>
-              </a:rPr>
-              <a:t>Thread creation and placement</a:t>
-            </a:r>
-            <a:endParaRPr lang="en-US" sz="1700" dirty="0"/>
-          </a:p>
-        </p:txBody>
-      </p:sp>
-      <p:sp>
-        <p:nvSpPr>
-          <p:cNvPr id="17" name="Text 15"/>
-          <p:cNvSpPr/>
-          <p:nvPr/>
-        </p:nvSpPr>
-        <p:spPr>
-          <a:xfrm>
-            <a:off x="1234440" y="4764024"/>
-            <a:ext cx="10241280" cy="868680"/>
-          </a:xfrm>
-          <a:prstGeom prst="rect">
-            <a:avLst/>
-          </a:prstGeom>
-          <a:noFill/>
-          <a:ln/>
-        </p:spPr>
-        <p:txBody>
-          <a:bodyPr wrap="square" lIns="0" tIns="0" rIns="0" bIns="0" rtlCol="0" anchor="t"/>
-          <a:lstStyle/>
-          <a:p>
-            <a:pPr indent="0" marL="0">
-              <a:buNone/>
-            </a:pPr>
-            <a:r>
-              <a:rPr lang="en-US" sz="1300" dirty="0">
-                <a:solidFill>
-                  <a:srgbClr val="52616B"/>
-                </a:solidFill>
-                <a:latin typeface="Calibri" pitchFamily="34" charset="0"/>
-                <a:ea typeface="Calibri" pitchFamily="34" charset="-122"/>
-                <a:cs typeface="Calibri" pitchFamily="34" charset="-120"/>
-              </a:rPr>
-              <a:t>pthread_create and join sit inside the timed region, and the scheduler does not spread threads across distinct physical cores — measured at 13.3%.</a:t>
-            </a:r>
-            <a:endParaRPr lang="en-US" sz="1300" dirty="0"/>
-          </a:p>
-        </p:txBody>
-      </p:sp>
-    </p:spTree>
-  </p:cSld>
-  <p:clrMapOvr>
-    <a:masterClrMapping/>
-  </p:clrMapOvr>
-</p:sld>
-</file>
-
 <file path=ppt/slides/slide12.xml><?xml version="1.0" encoding="utf-8"?>
 <p:sld xmlns:a="http://schemas.openxmlformats.org/drawingml/2006/main" xmlns:r="http://schemas.openxmlformats.org/officeDocument/2006/relationships" xmlns:p="http://schemas.openxmlformats.org/presentationml/2006/main">
   <p:cSld name="Slide 12">
@@ -7408,7 +6746,7 @@
         <p:spPr>
           <a:xfrm>
             <a:off x="548640" y="4892040"/>
-            <a:ext cx="11064240" cy="777240"/>
+            <a:ext cx="11064240" cy="1152000"/>
           </a:xfrm>
           <a:prstGeom prst="rect">
             <a:avLst/>
@@ -7433,6 +6771,26 @@
                 <a:cs typeface="Calibri" pitchFamily="34" charset="-120"/>
               </a:rPr>
               <a:t>The curve is a staircase rather than a smooth ramp: it jumps at 3→4 and 6→7 but stalls between 4 and 6. Past 8 threads every logical CPU is in use and the curve flattens — oversubscription as far as 32 threads costs almost nothing, because the workload is compute-bound.</a:t>
+            </a:r>
+            <a:endParaRPr lang="en-US" sz="1300" dirty="0"/>
+          </a:p>
+          <a:p>
+            <a:pPr indent="0" marL="0">
+              <a:spcBef>
+                <a:spcPts val="600"/>
+              </a:spcBef>
+              <a:buNone/>
+            </a:pPr>
+            <a:r>
+              <a:rPr lang="en-US" sz="1300" dirty="0">
+                <a:solidFill>
+                  <a:srgbClr val="52616B"/>
+                </a:solidFill>
+                <a:latin typeface="Calibri" pitchFamily="34" charset="0"/>
+                <a:ea typeface="Calibri" pitchFamily="34" charset="-122"/>
+                <a:cs typeface="Calibri" pitchFamily="34" charset="-120"/>
+              </a:rPr>
+              <a:t>1 thread is even slightly slower than serial (0.97×): the shared results[] array is compacted into the final sorted list by a single thread regardless of thread count — an O(n) pass that does not shrink as threads are added.</a:t>
             </a:r>
             <a:endParaRPr lang="en-US" sz="1300" dirty="0"/>
           </a:p>

</xml_diff>

<commit_message>
modified student 2 details in Title slide
</commit_message>
<xml_diff>
--- a/FIT3143_Lab1_Presentation.pptx
+++ b/FIT3143_Lab1_Presentation.pptx
@@ -4,6 +4,9 @@
   <p:sldMasterIdLst>
     <p:sldMasterId id="2147483648" r:id="rId1"/>
   </p:sldMasterIdLst>
+  <p:notesMasterIdLst>
+    <p:notesMasterId r:id="rId16"/>
+  </p:notesMasterIdLst>
   <p:sldIdLst>
     <p:sldId id="256" r:id="rId2"/>
     <p:sldId id="257" r:id="rId3"/>
@@ -15,14 +18,11 @@
     <p:sldId id="263" r:id="rId9"/>
     <p:sldId id="264" r:id="rId10"/>
     <p:sldId id="265" r:id="rId11"/>
-    <p:sldId id="267" r:id="rId13"/>
-    <p:sldId id="268" r:id="rId14"/>
-    <p:sldId id="269" r:id="rId15"/>
-    <p:sldId id="270" r:id="rId16"/>
+    <p:sldId id="267" r:id="rId12"/>
+    <p:sldId id="268" r:id="rId13"/>
+    <p:sldId id="269" r:id="rId14"/>
+    <p:sldId id="270" r:id="rId15"/>
   </p:sldIdLst>
-  <p:notesMasterIdLst>
-    <p:notesMasterId r:id="rId17"/>
-  </p:notesMasterIdLst>
   <p:sldSz cx="12192000" cy="6858000"/>
   <p:notesSz cx="6858000" cy="12192000"/>
   <p:defaultTextStyle>
@@ -117,6 +117,11 @@
       </a:defRPr>
     </a:lvl9pPr>
   </p:defaultTextStyle>
+  <p:extLst>
+    <p:ext uri="{EFAFB233-063F-42B5-8137-9DF3F51BA10A}">
+      <p15:sldGuideLst xmlns:p15="http://schemas.microsoft.com/office/powerpoint/2012/main"/>
+    </p:ext>
+  </p:extLst>
 </p:presentation>
 </file>
 
@@ -142,234 +147,10 @@
           <a:chExt cx="0" cy="0"/>
         </a:xfrm>
       </p:grpSpPr>
-      <p:sp>
-        <p:nvSpPr>
-          <p:cNvPr id="2" name="Header Placeholder 1"/>
-          <p:cNvSpPr>
-            <a:spLocks noGrp="1"/>
-          </p:cNvSpPr>
-          <p:nvPr>
-            <p:ph type="hdr" sz="quarter"/>
-          </p:nvPr>
-        </p:nvSpPr>
-        <p:spPr>
-          <a:xfrm>
-            <a:off x="0" y="0"/>
-            <a:ext cx="2971800" cy="458788"/>
-          </a:xfrm>
-          <a:prstGeom prst="rect">
-            <a:avLst/>
-          </a:prstGeom>
-        </p:spPr>
-        <p:txBody>
-          <a:bodyPr vert="horz" lIns="91440" tIns="45720" rIns="91440" bIns="45720" rtlCol="0"/>
-          <a:lstStyle>
-            <a:lvl1pPr algn="l">
-              <a:defRPr sz="1200"/>
-            </a:lvl1pPr>
-          </a:lstStyle>
-          <a:p>
-            <a:endParaRPr lang="en-US"/>
-          </a:p>
-        </p:txBody>
-      </p:sp>
-      <p:sp>
-        <p:nvSpPr>
-          <p:cNvPr id="3" name="Date Placeholder 2"/>
-          <p:cNvSpPr>
-            <a:spLocks noGrp="1"/>
-          </p:cNvSpPr>
-          <p:nvPr>
-            <p:ph type="dt" idx="1"/>
-          </p:nvPr>
-        </p:nvSpPr>
-        <p:spPr>
-          <a:xfrm>
-            <a:off x="3884613" y="0"/>
-            <a:ext cx="2971800" cy="458788"/>
-          </a:xfrm>
-          <a:prstGeom prst="rect">
-            <a:avLst/>
-          </a:prstGeom>
-        </p:spPr>
-        <p:txBody>
-          <a:bodyPr vert="horz" lIns="91440" tIns="45720" rIns="91440" bIns="45720" rtlCol="0"/>
-          <a:lstStyle>
-            <a:lvl1pPr algn="r">
-              <a:defRPr sz="1200"/>
-            </a:lvl1pPr>
-          </a:lstStyle>
-          <a:p>
-            <a:fld id="{5282F153-3F37-0F45-9E97-73ACFA13230C}" type="datetimeFigureOut">
-              <a:rPr lang="en-US"/>
-              <a:t>7/23/19</a:t>
-            </a:fld>
-            <a:endParaRPr lang="en-US"/>
-          </a:p>
-        </p:txBody>
-      </p:sp>
-      <p:sp>
-        <p:nvSpPr>
-          <p:cNvPr id="4" name="Slide Image Placeholder 3"/>
-          <p:cNvSpPr>
-            <a:spLocks noGrp="1" noRot="1" noChangeAspect="1"/>
-          </p:cNvSpPr>
-          <p:nvPr>
-            <p:ph type="sldImg" idx="2"/>
-          </p:nvPr>
-        </p:nvSpPr>
-        <p:spPr>
-          <a:xfrm>
-            <a:off x="685800" y="1143000"/>
-            <a:ext cx="5486400" cy="3086100"/>
-          </a:xfrm>
-          <a:prstGeom prst="rect">
-            <a:avLst/>
-          </a:prstGeom>
-          <a:noFill/>
-          <a:ln w="12700">
-            <a:solidFill>
-              <a:prstClr val="black"/>
-            </a:solidFill>
-          </a:ln>
-        </p:spPr>
-        <p:txBody>
-          <a:bodyPr vert="horz" lIns="91440" tIns="45720" rIns="91440" bIns="45720" rtlCol="0" anchor="ctr"/>
-          <a:lstStyle/>
-          <a:p>
-            <a:endParaRPr lang="en-US"/>
-          </a:p>
-        </p:txBody>
-      </p:sp>
-      <p:sp>
-        <p:nvSpPr>
-          <p:cNvPr id="5" name="Notes Placeholder 4"/>
-          <p:cNvSpPr>
-            <a:spLocks noGrp="1"/>
-          </p:cNvSpPr>
-          <p:nvPr>
-            <p:ph type="body" sz="quarter" idx="3"/>
-          </p:nvPr>
-        </p:nvSpPr>
-        <p:spPr>
-          <a:xfrm>
-            <a:off x="685800" y="4400550"/>
-            <a:ext cx="5486400" cy="3600450"/>
-          </a:xfrm>
-          <a:prstGeom prst="rect">
-            <a:avLst/>
-          </a:prstGeom>
-        </p:spPr>
-        <p:txBody>
-          <a:bodyPr vert="horz" lIns="91440" tIns="45720" rIns="91440" bIns="45720" rtlCol="0"/>
-          <a:lstStyle/>
-          <a:p>
-            <a:pPr lvl="0"/>
-            <a:r>
-              <a:rPr lang="en-US"/>
-              <a:t>Click to edit Master text styles</a:t>
-            </a:r>
-          </a:p>
-          <a:p>
-            <a:pPr lvl="1"/>
-            <a:r>
-              <a:rPr lang="en-US"/>
-              <a:t>Second level</a:t>
-            </a:r>
-          </a:p>
-          <a:p>
-            <a:pPr lvl="2"/>
-            <a:r>
-              <a:rPr lang="en-US"/>
-              <a:t>Third level</a:t>
-            </a:r>
-          </a:p>
-          <a:p>
-            <a:pPr lvl="3"/>
-            <a:r>
-              <a:rPr lang="en-US"/>
-              <a:t>Fourth level</a:t>
-            </a:r>
-          </a:p>
-          <a:p>
-            <a:pPr lvl="4"/>
-            <a:r>
-              <a:rPr lang="en-US"/>
-              <a:t>Fifth level</a:t>
-            </a:r>
-          </a:p>
-        </p:txBody>
-      </p:sp>
-      <p:sp>
-        <p:nvSpPr>
-          <p:cNvPr id="6" name="Footer Placeholder 5"/>
-          <p:cNvSpPr>
-            <a:spLocks noGrp="1"/>
-          </p:cNvSpPr>
-          <p:nvPr>
-            <p:ph type="ftr" sz="quarter" idx="4"/>
-          </p:nvPr>
-        </p:nvSpPr>
-        <p:spPr>
-          <a:xfrm>
-            <a:off x="0" y="8685213"/>
-            <a:ext cx="2971800" cy="458787"/>
-          </a:xfrm>
-          <a:prstGeom prst="rect">
-            <a:avLst/>
-          </a:prstGeom>
-        </p:spPr>
-        <p:txBody>
-          <a:bodyPr vert="horz" lIns="91440" tIns="45720" rIns="91440" bIns="45720" rtlCol="0" anchor="b"/>
-          <a:lstStyle>
-            <a:lvl1pPr algn="l">
-              <a:defRPr sz="1200"/>
-            </a:lvl1pPr>
-          </a:lstStyle>
-          <a:p>
-            <a:endParaRPr lang="en-US"/>
-          </a:p>
-        </p:txBody>
-      </p:sp>
-      <p:sp>
-        <p:nvSpPr>
-          <p:cNvPr id="7" name="Slide Number Placeholder 6"/>
-          <p:cNvSpPr>
-            <a:spLocks noGrp="1"/>
-          </p:cNvSpPr>
-          <p:nvPr>
-            <p:ph type="sldNum" sz="quarter" idx="5"/>
-          </p:nvPr>
-        </p:nvSpPr>
-        <p:spPr>
-          <a:xfrm>
-            <a:off x="3884613" y="8685213"/>
-            <a:ext cx="2971800" cy="458787"/>
-          </a:xfrm>
-          <a:prstGeom prst="rect">
-            <a:avLst/>
-          </a:prstGeom>
-        </p:spPr>
-        <p:txBody>
-          <a:bodyPr vert="horz" lIns="91440" tIns="45720" rIns="91440" bIns="45720" rtlCol="0" anchor="b"/>
-          <a:lstStyle>
-            <a:lvl1pPr algn="r">
-              <a:defRPr sz="1200"/>
-            </a:lvl1pPr>
-          </a:lstStyle>
-          <a:p>
-            <a:fld id="{CE5E9CC1-C706-0F49-92D6-E571CC5EEA8F}" type="slidenum">
-              <a:rPr lang="en-US"/>
-              <a:t>‹#›</a:t>
-            </a:fld>
-            <a:endParaRPr lang="en-US"/>
-          </a:p>
-        </p:txBody>
-      </p:sp>
     </p:spTree>
     <p:extLst>
       <p:ext uri="{BB962C8B-B14F-4D97-AF65-F5344CB8AC3E}">
-        <p14:creationId xmlns:p14="http://schemas.microsoft.com/office/powerpoint/2010/main" val="1024086991"/>
+        <p14:creationId xmlns:p14="http://schemas.microsoft.com/office/powerpoint/2010/main" val="1087051251"/>
       </p:ext>
     </p:extLst>
   </p:cSld>
@@ -517,7 +298,6 @@
               <a:rPr lang="en-US" dirty="0"/>
               <a:t>7 minutes total. Task 1 about 1 min, Task 2 about 3 min, Task 3 about 2 min, conclusion about 1 min.</a:t>
             </a:r>
-            <a:endParaRPr lang="en-US" dirty="0"/>
           </a:p>
         </p:txBody>
       </p:sp>
@@ -605,7 +385,6 @@
               <a:rPr lang="en-US" dirty="0"/>
               <a:t>This slide answers 'would you recommend OpenMP'. Performance is a tie; the difference is development effort and start-up cost.</a:t>
             </a:r>
-            <a:endParaRPr lang="en-US" dirty="0"/>
           </a:p>
         </p:txBody>
       </p:sp>
@@ -627,6 +406,93 @@
             <a:fld id="{F7021451-1387-4CA6-816F-3879F97B5CBC}" type="slidenum">
               <a:rPr lang="en-US"/>
               <a:t>10</a:t>
+            </a:fld>
+            <a:endParaRPr lang="en-US"/>
+          </a:p>
+        </p:txBody>
+      </p:sp>
+    </p:spTree>
+    <p:extLst>
+      <p:ext uri="{BB962C8B-B14F-4D97-AF65-F5344CB8AC3E}">
+        <p14:creationId xmlns:p14="http://schemas.microsoft.com/office/powerpoint/2010/main" val="1024086991"/>
+      </p:ext>
+    </p:extLst>
+  </p:cSld>
+  <p:clrMapOvr>
+    <a:masterClrMapping/>
+  </p:clrMapOvr>
+</p:notes>
+</file>
+
+<file path=ppt/notesSlides/notesSlide11.xml><?xml version="1.0" encoding="utf-8"?>
+<p:notes xmlns:a="http://schemas.openxmlformats.org/drawingml/2006/main" xmlns:r="http://schemas.openxmlformats.org/officeDocument/2006/relationships" xmlns:p="http://schemas.openxmlformats.org/presentationml/2006/main">
+  <p:cSld>
+    <p:spTree>
+      <p:nvGrpSpPr>
+        <p:cNvPr id="1" name=""/>
+        <p:cNvGrpSpPr/>
+        <p:nvPr/>
+      </p:nvGrpSpPr>
+      <p:grpSpPr>
+        <a:xfrm>
+          <a:off x="0" y="0"/>
+          <a:ext cx="0" cy="0"/>
+          <a:chOff x="0" y="0"/>
+          <a:chExt cx="0" cy="0"/>
+        </a:xfrm>
+      </p:grpSpPr>
+      <p:sp>
+        <p:nvSpPr>
+          <p:cNvPr id="2" name="Slide Image Placeholder 1"/>
+          <p:cNvSpPr>
+            <a:spLocks noGrp="1" noRot="1" noChangeAspect="1"/>
+          </p:cNvSpPr>
+          <p:nvPr>
+            <p:ph type="sldImg"/>
+          </p:nvPr>
+        </p:nvSpPr>
+        <p:spPr/>
+      </p:sp>
+      <p:sp>
+        <p:nvSpPr>
+          <p:cNvPr id="3" name="Notes Placeholder 2"/>
+          <p:cNvSpPr>
+            <a:spLocks noGrp="1"/>
+          </p:cNvSpPr>
+          <p:nvPr>
+            <p:ph type="body" idx="1"/>
+          </p:nvPr>
+        </p:nvSpPr>
+        <p:spPr/>
+        <p:txBody>
+          <a:bodyPr/>
+          <a:lstStyle/>
+          <a:p>
+            <a:r>
+              <a:rPr lang="en-US" dirty="0"/>
+              <a:t>Land on the last line. It is the single sentence worth remembering.</a:t>
+            </a:r>
+          </a:p>
+        </p:txBody>
+      </p:sp>
+      <p:sp>
+        <p:nvSpPr>
+          <p:cNvPr id="4" name="Slide Number Placeholder 3"/>
+          <p:cNvSpPr>
+            <a:spLocks noGrp="1"/>
+          </p:cNvSpPr>
+          <p:nvPr>
+            <p:ph type="sldNum" sz="quarter" idx="10"/>
+          </p:nvPr>
+        </p:nvSpPr>
+        <p:spPr/>
+        <p:txBody>
+          <a:bodyPr/>
+          <a:lstStyle/>
+          <a:p>
+            <a:fld id="{F7021451-1387-4CA6-816F-3879F97B5CBC}" type="slidenum">
+              <a:rPr lang="en-US"/>
+              <a:t>11</a:t>
             </a:fld>
             <a:endParaRPr lang="en-US"/>
           </a:p>
@@ -691,9 +557,8 @@
           <a:p>
             <a:r>
               <a:rPr lang="en-US" dirty="0"/>
-              <a:t>Land on the last line. It is the single sentence worth remembering.</a:t>
-            </a:r>
-            <a:endParaRPr lang="en-US" dirty="0"/>
+              <a:t>Appendix slides follow: methodology and the AI declaration.</a:t>
+            </a:r>
           </a:p>
         </p:txBody>
       </p:sp>
@@ -779,9 +644,8 @@
           <a:p>
             <a:r>
               <a:rPr lang="en-US" dirty="0"/>
-              <a:t>Appendix slides follow: methodology and the AI declaration.</a:t>
-            </a:r>
-            <a:endParaRPr lang="en-US" dirty="0"/>
+              <a:t>Reference only.</a:t>
+            </a:r>
           </a:p>
         </p:txBody>
       </p:sp>
@@ -867,9 +731,8 @@
           <a:p>
             <a:r>
               <a:rPr lang="en-US" dirty="0"/>
-              <a:t>Reference only.</a:t>
-            </a:r>
-            <a:endParaRPr lang="en-US" dirty="0"/>
+              <a:t>Fill in the brackets before submission.</a:t>
+            </a:r>
           </a:p>
         </p:txBody>
       </p:sp>
@@ -891,94 +754,6 @@
             <a:fld id="{F7021451-1387-4CA6-816F-3879F97B5CBC}" type="slidenum">
               <a:rPr lang="en-US"/>
               <a:t>14</a:t>
-            </a:fld>
-            <a:endParaRPr lang="en-US"/>
-          </a:p>
-        </p:txBody>
-      </p:sp>
-    </p:spTree>
-    <p:extLst>
-      <p:ext uri="{BB962C8B-B14F-4D97-AF65-F5344CB8AC3E}">
-        <p14:creationId xmlns:p14="http://schemas.microsoft.com/office/powerpoint/2010/main" val="1024086991"/>
-      </p:ext>
-    </p:extLst>
-  </p:cSld>
-  <p:clrMapOvr>
-    <a:masterClrMapping/>
-  </p:clrMapOvr>
-</p:notes>
-</file>
-
-<file path=ppt/notesSlides/notesSlide15.xml><?xml version="1.0" encoding="utf-8"?>
-<p:notes xmlns:a="http://schemas.openxmlformats.org/drawingml/2006/main" xmlns:r="http://schemas.openxmlformats.org/officeDocument/2006/relationships" xmlns:p="http://schemas.openxmlformats.org/presentationml/2006/main">
-  <p:cSld>
-    <p:spTree>
-      <p:nvGrpSpPr>
-        <p:cNvPr id="1" name=""/>
-        <p:cNvGrpSpPr/>
-        <p:nvPr/>
-      </p:nvGrpSpPr>
-      <p:grpSpPr>
-        <a:xfrm>
-          <a:off x="0" y="0"/>
-          <a:ext cx="0" cy="0"/>
-          <a:chOff x="0" y="0"/>
-          <a:chExt cx="0" cy="0"/>
-        </a:xfrm>
-      </p:grpSpPr>
-      <p:sp>
-        <p:nvSpPr>
-          <p:cNvPr id="2" name="Slide Image Placeholder 1"/>
-          <p:cNvSpPr>
-            <a:spLocks noGrp="1" noRot="1" noChangeAspect="1"/>
-          </p:cNvSpPr>
-          <p:nvPr>
-            <p:ph type="sldImg"/>
-          </p:nvPr>
-        </p:nvSpPr>
-        <p:spPr/>
-      </p:sp>
-      <p:sp>
-        <p:nvSpPr>
-          <p:cNvPr id="3" name="Notes Placeholder 2"/>
-          <p:cNvSpPr>
-            <a:spLocks noGrp="1"/>
-          </p:cNvSpPr>
-          <p:nvPr>
-            <p:ph type="body" idx="1"/>
-          </p:nvPr>
-        </p:nvSpPr>
-        <p:spPr/>
-        <p:txBody>
-          <a:bodyPr/>
-          <a:lstStyle/>
-          <a:p>
-            <a:r>
-              <a:rPr lang="en-US" dirty="0"/>
-              <a:t>Fill in the brackets before submission.</a:t>
-            </a:r>
-            <a:endParaRPr lang="en-US" dirty="0"/>
-          </a:p>
-        </p:txBody>
-      </p:sp>
-      <p:sp>
-        <p:nvSpPr>
-          <p:cNvPr id="4" name="Slide Number Placeholder 3"/>
-          <p:cNvSpPr>
-            <a:spLocks noGrp="1"/>
-          </p:cNvSpPr>
-          <p:nvPr>
-            <p:ph type="sldNum" sz="quarter" idx="10"/>
-          </p:nvPr>
-        </p:nvSpPr>
-        <p:spPr/>
-        <p:txBody>
-          <a:bodyPr/>
-          <a:lstStyle/>
-          <a:p>
-            <a:fld id="{F7021451-1387-4CA6-816F-3879F97B5CBC}" type="slidenum">
-              <a:rPr lang="en-US"/>
-              <a:t>15</a:t>
             </a:fld>
             <a:endParaRPr lang="en-US"/>
           </a:p>
@@ -1045,7 +820,6 @@
               <a:rPr lang="en-US" dirty="0"/>
               <a:t>Keep this to about 30 seconds. The sqrt cutoff and the odd-divisor skip are the two optimisations measured on the next slide.</a:t>
             </a:r>
-            <a:endParaRPr lang="en-US" dirty="0"/>
           </a:p>
         </p:txBody>
       </p:sp>
@@ -1133,7 +907,6 @@
               <a:rPr lang="en-US" dirty="0"/>
               <a:t>The punch line: algorithmic optimisation bought three orders of magnitude; parallelisation buys five times. Optimise before you parallelise.</a:t>
             </a:r>
-            <a:endParaRPr lang="en-US" dirty="0"/>
           </a:p>
         </p:txBody>
       </p:sp>
@@ -1221,7 +994,6 @@
               <a:rPr lang="en-US" dirty="0"/>
               <a:t>This is the central design decision of Task 2. Spend about 45 seconds here.</a:t>
             </a:r>
-            <a:endParaRPr lang="en-US" dirty="0"/>
           </a:p>
         </p:txBody>
       </p:sp>
@@ -1309,7 +1081,6 @@
               <a:rPr lang="en-US" dirty="0"/>
               <a:t>Point at the break-even crossing, then at the peak above the four-core reference line.</a:t>
             </a:r>
-            <a:endParaRPr lang="en-US" dirty="0"/>
           </a:p>
         </p:txBody>
       </p:sp>
@@ -1397,7 +1168,6 @@
               <a:rPr lang="en-US" dirty="0"/>
               <a:t>The staircase is not noise. The next slide shows what causes it.</a:t>
             </a:r>
-            <a:endParaRPr lang="en-US" dirty="0"/>
           </a:p>
         </p:txBody>
       </p:sp>
@@ -1485,7 +1255,6 @@
               <a:rPr lang="en-US" dirty="0"/>
               <a:t>Say plainly: our first implementation used contiguous blocks, we measured the imbalance, then fixed it.</a:t>
             </a:r>
-            <a:endParaRPr lang="en-US" dirty="0"/>
           </a:p>
         </p:txBody>
       </p:sp>
@@ -1573,7 +1342,6 @@
               <a:rPr lang="en-US" dirty="0"/>
               <a:t>A single run first suggested guided was 9.7% faster. Repeating it five times made the difference vanish. Mention this if asked about methodology.</a:t>
             </a:r>
-            <a:endParaRPr lang="en-US" dirty="0"/>
           </a:p>
         </p:txBody>
       </p:sp>
@@ -1661,7 +1429,6 @@
               <a:rPr lang="en-US" dirty="0"/>
               <a:t>Contrast with slide 5: OpenMP pays a larger fixed start-up cost.</a:t>
             </a:r>
-            <a:endParaRPr lang="en-US" dirty="0"/>
           </a:p>
         </p:txBody>
       </p:sp>
@@ -1734,6 +1501,11 @@
 <file path=ppt/slideMasters/slideMaster1.xml><?xml version="1.0" encoding="utf-8"?>
 <p:sldMaster xmlns:a="http://schemas.openxmlformats.org/drawingml/2006/main" xmlns:r="http://schemas.openxmlformats.org/officeDocument/2006/relationships" xmlns:p="http://schemas.openxmlformats.org/presentationml/2006/main">
   <p:cSld>
+    <p:bg>
+      <p:bgRef idx="1001">
+        <a:schemeClr val="bg1"/>
+      </p:bgRef>
+    </p:bg>
     <p:spTree>
       <p:nvGrpSpPr>
         <p:cNvPr id="1" name=""/>
@@ -2016,6 +1788,7 @@
         <a:solidFill>
           <a:srgbClr val="263238"/>
         </a:solidFill>
+        <a:effectLst/>
       </p:bgPr>
     </p:bg>
     <p:spTree>
@@ -2053,7 +1826,7 @@
           <a:bodyPr wrap="square" lIns="0" tIns="0" rIns="0" bIns="0" rtlCol="0" anchor="ctr"/>
           <a:lstStyle/>
           <a:p>
-            <a:pPr indent="0" marL="0">
+            <a:pPr marL="0" indent="0">
               <a:buNone/>
             </a:pPr>
             <a:r>
@@ -2092,7 +1865,7 @@
           <a:bodyPr wrap="square" lIns="0" tIns="0" rIns="0" bIns="0" rtlCol="0" anchor="ctr"/>
           <a:lstStyle/>
           <a:p>
-            <a:pPr indent="0" marL="0">
+            <a:pPr marL="0" indent="0">
               <a:buNone/>
             </a:pPr>
             <a:r>
@@ -2154,7 +1927,7 @@
           <a:bodyPr wrap="square" lIns="0" tIns="0" rIns="0" bIns="0" rtlCol="0" anchor="ctr"/>
           <a:lstStyle/>
           <a:p>
-            <a:pPr indent="0" marL="0">
+            <a:pPr marL="0" indent="0">
               <a:lnSpc>
                 <a:spcPts val="2400"/>
               </a:lnSpc>
@@ -2174,7 +1947,7 @@
             <a:endParaRPr lang="en-US" sz="1400" dirty="0"/>
           </a:p>
           <a:p>
-            <a:pPr indent="0" marL="0">
+            <a:pPr marL="0" indent="0">
               <a:lnSpc>
                 <a:spcPts val="2400"/>
               </a:lnSpc>
@@ -2189,7 +1962,18 @@
                 <a:ea typeface="Calibri" pitchFamily="34" charset="-122"/>
                 <a:cs typeface="Calibri" pitchFamily="34" charset="-120"/>
               </a:rPr>
-              <a:t>[Student 2 name]  ·  [ID]  ·  [name@student.monash.edu]</a:t>
+              <a:t>Hiew Jia Hao ·  34533664  </a:t>
+            </a:r>
+            <a:r>
+              <a:rPr lang="en-US" sz="1400">
+                <a:solidFill>
+                  <a:srgbClr val="C6CDD1"/>
+                </a:solidFill>
+                <a:latin typeface="Calibri" pitchFamily="34" charset="0"/>
+                <a:ea typeface="Calibri" pitchFamily="34" charset="-122"/>
+                <a:cs typeface="Calibri" pitchFamily="34" charset="-120"/>
+              </a:rPr>
+              <a:t>·  jhie0006@student.monash.edu</a:t>
             </a:r>
             <a:endParaRPr lang="en-US" sz="1400" dirty="0"/>
           </a:p>
@@ -2216,7 +2000,7 @@
           <a:bodyPr wrap="square" lIns="0" tIns="0" rIns="0" bIns="0" rtlCol="0" anchor="ctr"/>
           <a:lstStyle/>
           <a:p>
-            <a:pPr indent="0" marL="0">
+            <a:pPr marL="0" indent="0">
               <a:buNone/>
             </a:pPr>
             <a:r>
@@ -2300,7 +2084,7 @@
           <a:bodyPr wrap="square" lIns="0" tIns="0" rIns="0" bIns="0" rtlCol="0" anchor="ctr"/>
           <a:lstStyle/>
           <a:p>
-            <a:pPr algn="ctr" indent="0" marL="0">
+            <a:pPr marL="0" indent="0" algn="ctr">
               <a:buNone/>
             </a:pPr>
             <a:r>
@@ -2339,7 +2123,7 @@
           <a:bodyPr wrap="square" lIns="0" tIns="0" rIns="0" bIns="0" rtlCol="0" anchor="ctr"/>
           <a:lstStyle/>
           <a:p>
-            <a:pPr indent="0" marL="0">
+            <a:pPr marL="0" indent="0">
               <a:buNone/>
             </a:pPr>
             <a:r>
@@ -2378,7 +2162,7 @@
           <a:bodyPr wrap="square" lIns="0" tIns="0" rIns="0" bIns="0" rtlCol="0" anchor="ctr"/>
           <a:lstStyle/>
           <a:p>
-            <a:pPr indent="0" marL="0">
+            <a:pPr marL="0" indent="0">
               <a:buNone/>
             </a:pPr>
             <a:r>
@@ -2398,14 +2182,14 @@
       </p:sp>
       <p:pic>
         <p:nvPicPr>
-          <p:cNvPr id="6" name="Image 0" descr="C:/Users/hrt_i/Monash/Fit3143/fit3143-lab1/graphs/graph7_runtime_vs_n_pthread_openmp.png">    </p:cNvPr>
+          <p:cNvPr id="6" name="Image 0" descr="C:/Users/hrt_i/Monash/Fit3143/fit3143-lab1/graphs/graph7_runtime_vs_n_pthread_openmp.png"/>
           <p:cNvPicPr>
             <a:picLocks noChangeAspect="1"/>
           </p:cNvPicPr>
           <p:nvPr/>
         </p:nvPicPr>
         <p:blipFill>
-          <a:blip r:embed="rId1"/>
+          <a:blip r:embed="rId3"/>
           <a:stretch>
             <a:fillRect/>
           </a:stretch>
@@ -2422,14 +2206,14 @@
       </p:pic>
       <p:pic>
         <p:nvPicPr>
-          <p:cNvPr id="7" name="Image 1" descr="C:/Users/hrt_i/Monash/Fit3143/fit3143-lab1/graphs/graph8_runtime_vs_threads_pthread_openmp.png">    </p:cNvPr>
+          <p:cNvPr id="7" name="Image 1" descr="C:/Users/hrt_i/Monash/Fit3143/fit3143-lab1/graphs/graph8_runtime_vs_threads_pthread_openmp.png"/>
           <p:cNvPicPr>
             <a:picLocks noChangeAspect="1"/>
           </p:cNvPicPr>
           <p:nvPr/>
         </p:nvPicPr>
         <p:blipFill>
-          <a:blip r:embed="rId2"/>
+          <a:blip r:embed="rId4"/>
           <a:stretch>
             <a:fillRect/>
           </a:stretch>
@@ -2465,7 +2249,7 @@
           <a:bodyPr wrap="square" lIns="0" tIns="0" rIns="0" bIns="0" rtlCol="0" anchor="t"/>
           <a:lstStyle/>
           <a:p>
-            <a:pPr indent="0" marL="0">
+            <a:pPr marL="0" indent="0">
               <a:buNone/>
             </a:pPr>
             <a:r>
@@ -2491,7 +2275,7 @@
 </p:sld>
 </file>
 
-<file path=ppt/slides/slide12.xml><?xml version="1.0" encoding="utf-8"?>
+<file path=ppt/slides/slide11.xml><?xml version="1.0" encoding="utf-8"?>
 <p:sld xmlns:a="http://schemas.openxmlformats.org/drawingml/2006/main" xmlns:r="http://schemas.openxmlformats.org/officeDocument/2006/relationships" xmlns:p="http://schemas.openxmlformats.org/presentationml/2006/main">
   <p:cSld name="Slide 12">
     <p:bg>
@@ -2499,6 +2283,7 @@
         <a:solidFill>
           <a:srgbClr val="263238"/>
         </a:solidFill>
+        <a:effectLst/>
       </p:bgPr>
     </p:bg>
     <p:spTree>
@@ -2536,7 +2321,7 @@
           <a:bodyPr wrap="square" lIns="0" tIns="0" rIns="0" bIns="0" rtlCol="0" anchor="ctr"/>
           <a:lstStyle/>
           <a:p>
-            <a:pPr indent="0" marL="0">
+            <a:pPr marL="0" indent="0">
               <a:buNone/>
             </a:pPr>
             <a:r>
@@ -2595,7 +2380,7 @@
           <a:bodyPr wrap="square" lIns="0" tIns="0" rIns="0" bIns="0" rtlCol="0" anchor="ctr"/>
           <a:lstStyle/>
           <a:p>
-            <a:pPr indent="0" marL="0">
+            <a:pPr marL="0" indent="0">
               <a:buNone/>
             </a:pPr>
             <a:r>
@@ -2748,7 +2533,7 @@
           <a:bodyPr wrap="square" lIns="0" tIns="0" rIns="0" bIns="0" rtlCol="0" anchor="ctr"/>
           <a:lstStyle/>
           <a:p>
-            <a:pPr indent="0" marL="0">
+            <a:pPr marL="0" indent="0">
               <a:buNone/>
             </a:pPr>
             <a:r>
@@ -2901,7 +2686,7 @@
           <a:bodyPr wrap="square" lIns="0" tIns="0" rIns="0" bIns="0" rtlCol="0" anchor="ctr"/>
           <a:lstStyle/>
           <a:p>
-            <a:pPr indent="0" marL="0">
+            <a:pPr marL="0" indent="0">
               <a:buNone/>
             </a:pPr>
             <a:r>
@@ -3034,7 +2819,7 @@
           <a:bodyPr wrap="square" lIns="0" tIns="0" rIns="0" bIns="0" rtlCol="0" anchor="ctr"/>
           <a:lstStyle/>
           <a:p>
-            <a:pPr indent="0" marL="0">
+            <a:pPr marL="0" indent="0">
               <a:buNone/>
             </a:pPr>
             <a:r>
@@ -3060,7 +2845,7 @@
 </p:sld>
 </file>
 
-<file path=ppt/slides/slide13.xml><?xml version="1.0" encoding="utf-8"?>
+<file path=ppt/slides/slide12.xml><?xml version="1.0" encoding="utf-8"?>
 <p:sld xmlns:a="http://schemas.openxmlformats.org/drawingml/2006/main" xmlns:r="http://schemas.openxmlformats.org/officeDocument/2006/relationships" xmlns:p="http://schemas.openxmlformats.org/presentationml/2006/main">
   <p:cSld name="Slide 13">
     <p:bg>
@@ -3068,6 +2853,7 @@
         <a:solidFill>
           <a:srgbClr val="263238"/>
         </a:solidFill>
+        <a:effectLst/>
       </p:bgPr>
     </p:bg>
     <p:spTree>
@@ -3105,7 +2891,7 @@
           <a:bodyPr wrap="square" lIns="0" tIns="0" rIns="0" bIns="0" rtlCol="0" anchor="ctr"/>
           <a:lstStyle/>
           <a:p>
-            <a:pPr indent="0" marL="0">
+            <a:pPr marL="0" indent="0">
               <a:buNone/>
             </a:pPr>
             <a:r>
@@ -3144,7 +2930,7 @@
           <a:bodyPr wrap="square" lIns="0" tIns="0" rIns="0" bIns="0" rtlCol="0" anchor="ctr"/>
           <a:lstStyle/>
           <a:p>
-            <a:pPr indent="0" marL="0">
+            <a:pPr marL="0" indent="0">
               <a:buNone/>
             </a:pPr>
             <a:r>
@@ -3170,7 +2956,7 @@
 </p:sld>
 </file>
 
-<file path=ppt/slides/slide14.xml><?xml version="1.0" encoding="utf-8"?>
+<file path=ppt/slides/slide13.xml><?xml version="1.0" encoding="utf-8"?>
 <p:sld xmlns:a="http://schemas.openxmlformats.org/drawingml/2006/main" xmlns:r="http://schemas.openxmlformats.org/officeDocument/2006/relationships" xmlns:p="http://schemas.openxmlformats.org/presentationml/2006/main">
   <p:cSld name="Slide 14">
     <p:spTree>
@@ -3228,7 +3014,7 @@
           <a:bodyPr wrap="square" lIns="0" tIns="0" rIns="0" bIns="0" rtlCol="0" anchor="ctr"/>
           <a:lstStyle/>
           <a:p>
-            <a:pPr algn="ctr" indent="0" marL="0">
+            <a:pPr marL="0" indent="0" algn="ctr">
               <a:buNone/>
             </a:pPr>
             <a:r>
@@ -3267,7 +3053,7 @@
           <a:bodyPr wrap="square" lIns="0" tIns="0" rIns="0" bIns="0" rtlCol="0" anchor="ctr"/>
           <a:lstStyle/>
           <a:p>
-            <a:pPr indent="0" marL="0">
+            <a:pPr marL="0" indent="0">
               <a:buNone/>
             </a:pPr>
             <a:r>
@@ -3306,7 +3092,7 @@
           <a:bodyPr wrap="square" lIns="0" tIns="0" rIns="0" bIns="0" rtlCol="0" anchor="ctr"/>
           <a:lstStyle/>
           <a:p>
-            <a:pPr indent="0" marL="0">
+            <a:pPr marL="0" indent="0">
               <a:buNone/>
             </a:pPr>
             <a:r>
@@ -3498,7 +3284,7 @@
 </p:sld>
 </file>
 
-<file path=ppt/slides/slide15.xml><?xml version="1.0" encoding="utf-8"?>
+<file path=ppt/slides/slide14.xml><?xml version="1.0" encoding="utf-8"?>
 <p:sld xmlns:a="http://schemas.openxmlformats.org/drawingml/2006/main" xmlns:r="http://schemas.openxmlformats.org/officeDocument/2006/relationships" xmlns:p="http://schemas.openxmlformats.org/presentationml/2006/main">
   <p:cSld name="Slide 15">
     <p:spTree>
@@ -3556,7 +3342,7 @@
           <a:bodyPr wrap="square" lIns="0" tIns="0" rIns="0" bIns="0" rtlCol="0" anchor="ctr"/>
           <a:lstStyle/>
           <a:p>
-            <a:pPr algn="ctr" indent="0" marL="0">
+            <a:pPr marL="0" indent="0" algn="ctr">
               <a:buNone/>
             </a:pPr>
             <a:r>
@@ -3595,7 +3381,7 @@
           <a:bodyPr wrap="square" lIns="0" tIns="0" rIns="0" bIns="0" rtlCol="0" anchor="ctr"/>
           <a:lstStyle/>
           <a:p>
-            <a:pPr indent="0" marL="0">
+            <a:pPr marL="0" indent="0">
               <a:buNone/>
             </a:pPr>
             <a:r>
@@ -3634,7 +3420,7 @@
           <a:bodyPr wrap="square" lIns="0" tIns="0" rIns="0" bIns="0" rtlCol="0" anchor="ctr"/>
           <a:lstStyle/>
           <a:p>
-            <a:pPr indent="0" marL="0">
+            <a:pPr marL="0" indent="0">
               <a:buNone/>
             </a:pPr>
             <a:r>
@@ -3842,7 +3628,7 @@
           <a:bodyPr wrap="square" lIns="0" tIns="0" rIns="0" bIns="0" rtlCol="0" anchor="ctr"/>
           <a:lstStyle/>
           <a:p>
-            <a:pPr indent="0" marL="0">
+            <a:pPr marL="0" indent="0">
               <a:buNone/>
             </a:pPr>
             <a:r>
@@ -3926,7 +3712,7 @@
           <a:bodyPr wrap="square" lIns="0" tIns="0" rIns="0" bIns="0" rtlCol="0" anchor="ctr"/>
           <a:lstStyle/>
           <a:p>
-            <a:pPr algn="ctr" indent="0" marL="0">
+            <a:pPr marL="0" indent="0" algn="ctr">
               <a:buNone/>
             </a:pPr>
             <a:r>
@@ -3965,7 +3751,7 @@
           <a:bodyPr wrap="square" lIns="0" tIns="0" rIns="0" bIns="0" rtlCol="0" anchor="ctr"/>
           <a:lstStyle/>
           <a:p>
-            <a:pPr indent="0" marL="0">
+            <a:pPr marL="0" indent="0">
               <a:buNone/>
             </a:pPr>
             <a:r>
@@ -4004,7 +3790,7 @@
           <a:bodyPr wrap="square" lIns="0" tIns="0" rIns="0" bIns="0" rtlCol="0" anchor="ctr"/>
           <a:lstStyle/>
           <a:p>
-            <a:pPr indent="0" marL="0">
+            <a:pPr marL="0" indent="0">
               <a:buNone/>
             </a:pPr>
             <a:r>
@@ -4188,7 +3974,7 @@
           <a:bodyPr wrap="square" lIns="0" tIns="0" rIns="0" bIns="0" rtlCol="0" anchor="ctr"/>
           <a:lstStyle/>
           <a:p>
-            <a:pPr indent="0" marL="0">
+            <a:pPr marL="0" indent="0">
               <a:lnSpc>
                 <a:spcPts val="1900"/>
               </a:lnSpc>
@@ -4208,7 +3994,7 @@
             <a:endParaRPr lang="en-US" sz="1100" dirty="0"/>
           </a:p>
           <a:p>
-            <a:pPr indent="0" marL="0">
+            <a:pPr marL="0" indent="0">
               <a:lnSpc>
                 <a:spcPts val="1900"/>
               </a:lnSpc>
@@ -4228,7 +4014,7 @@
             <a:endParaRPr lang="en-US" sz="1100" dirty="0"/>
           </a:p>
           <a:p>
-            <a:pPr indent="0" marL="0">
+            <a:pPr marL="0" indent="0">
               <a:lnSpc>
                 <a:spcPts val="1900"/>
               </a:lnSpc>
@@ -4248,7 +4034,7 @@
             <a:endParaRPr lang="en-US" sz="1100" dirty="0"/>
           </a:p>
           <a:p>
-            <a:pPr indent="0" marL="0">
+            <a:pPr marL="0" indent="0">
               <a:lnSpc>
                 <a:spcPts val="1900"/>
               </a:lnSpc>
@@ -4268,7 +4054,7 @@
             <a:endParaRPr lang="en-US" sz="1100" dirty="0"/>
           </a:p>
           <a:p>
-            <a:pPr indent="0" marL="0">
+            <a:pPr marL="0" indent="0">
               <a:lnSpc>
                 <a:spcPts val="1900"/>
               </a:lnSpc>
@@ -4288,7 +4074,7 @@
             <a:endParaRPr lang="en-US" sz="1100" dirty="0"/>
           </a:p>
           <a:p>
-            <a:pPr indent="0" marL="0">
+            <a:pPr marL="0" indent="0">
               <a:lnSpc>
                 <a:spcPts val="1900"/>
               </a:lnSpc>
@@ -4308,7 +4094,7 @@
             <a:endParaRPr lang="en-US" sz="1100" dirty="0"/>
           </a:p>
           <a:p>
-            <a:pPr indent="0" marL="0">
+            <a:pPr marL="0" indent="0">
               <a:lnSpc>
                 <a:spcPts val="1900"/>
               </a:lnSpc>
@@ -4328,7 +4114,7 @@
             <a:endParaRPr lang="en-US" sz="1100" dirty="0"/>
           </a:p>
           <a:p>
-            <a:pPr indent="0" marL="0">
+            <a:pPr marL="0" indent="0">
               <a:lnSpc>
                 <a:spcPts val="1900"/>
               </a:lnSpc>
@@ -4348,7 +4134,7 @@
             <a:endParaRPr lang="en-US" sz="1100" dirty="0"/>
           </a:p>
           <a:p>
-            <a:pPr indent="0" marL="0">
+            <a:pPr marL="0" indent="0">
               <a:lnSpc>
                 <a:spcPts val="1900"/>
               </a:lnSpc>
@@ -4390,7 +4176,7 @@
           <a:bodyPr wrap="square" lIns="0" tIns="0" rIns="0" bIns="0" rtlCol="0" anchor="t"/>
           <a:lstStyle/>
           <a:p>
-            <a:pPr indent="0" marL="0">
+            <a:pPr marL="0" indent="0">
               <a:buNone/>
             </a:pPr>
             <a:r>
@@ -4474,7 +4260,7 @@
           <a:bodyPr wrap="square" lIns="0" tIns="0" rIns="0" bIns="0" rtlCol="0" anchor="ctr"/>
           <a:lstStyle/>
           <a:p>
-            <a:pPr algn="ctr" indent="0" marL="0">
+            <a:pPr marL="0" indent="0" algn="ctr">
               <a:buNone/>
             </a:pPr>
             <a:r>
@@ -4513,7 +4299,7 @@
           <a:bodyPr wrap="square" lIns="0" tIns="0" rIns="0" bIns="0" rtlCol="0" anchor="ctr"/>
           <a:lstStyle/>
           <a:p>
-            <a:pPr indent="0" marL="0">
+            <a:pPr marL="0" indent="0">
               <a:buNone/>
             </a:pPr>
             <a:r>
@@ -4552,7 +4338,7 @@
           <a:bodyPr wrap="square" lIns="0" tIns="0" rIns="0" bIns="0" rtlCol="0" anchor="ctr"/>
           <a:lstStyle/>
           <a:p>
-            <a:pPr indent="0" marL="0">
+            <a:pPr marL="0" indent="0">
               <a:buNone/>
             </a:pPr>
             <a:r>
@@ -4572,14 +4358,14 @@
       </p:sp>
       <p:pic>
         <p:nvPicPr>
-          <p:cNvPr id="6" name="Image 0" descr="C:/Users/hrt_i/Monash/Fit3143/fit3143-lab1/graphs/graph0_task1_optimisation.png">    </p:cNvPr>
+          <p:cNvPr id="6" name="Image 0" descr="C:/Users/hrt_i/Monash/Fit3143/fit3143-lab1/graphs/graph0_task1_optimisation.png"/>
           <p:cNvPicPr>
             <a:picLocks noChangeAspect="1"/>
           </p:cNvPicPr>
           <p:nvPr/>
         </p:nvPicPr>
         <p:blipFill>
-          <a:blip r:embed="rId1"/>
+          <a:blip r:embed="rId3"/>
           <a:stretch>
             <a:fillRect/>
           </a:stretch>
@@ -4642,7 +4428,7 @@
           <a:bodyPr wrap="square" lIns="0" tIns="0" rIns="0" bIns="0" rtlCol="0" anchor="ctr"/>
           <a:lstStyle/>
           <a:p>
-            <a:pPr algn="ctr" indent="0" marL="0">
+            <a:pPr marL="0" indent="0" algn="ctr">
               <a:buNone/>
             </a:pPr>
             <a:r>
@@ -4681,7 +4467,7 @@
           <a:bodyPr wrap="square" lIns="0" tIns="0" rIns="0" bIns="0" rtlCol="0" anchor="t"/>
           <a:lstStyle/>
           <a:p>
-            <a:pPr algn="ctr" indent="0" marL="0">
+            <a:pPr marL="0" indent="0" algn="ctr">
               <a:buNone/>
             </a:pPr>
             <a:r>
@@ -4747,7 +4533,7 @@
           <a:bodyPr wrap="square" lIns="0" tIns="0" rIns="0" bIns="0" rtlCol="0" anchor="ctr"/>
           <a:lstStyle/>
           <a:p>
-            <a:pPr algn="ctr" indent="0" marL="0">
+            <a:pPr marL="0" indent="0" algn="ctr">
               <a:buNone/>
             </a:pPr>
             <a:r>
@@ -4786,7 +4572,7 @@
           <a:bodyPr wrap="square" lIns="0" tIns="0" rIns="0" bIns="0" rtlCol="0" anchor="t"/>
           <a:lstStyle/>
           <a:p>
-            <a:pPr algn="ctr" indent="0" marL="0">
+            <a:pPr marL="0" indent="0" algn="ctr">
               <a:buNone/>
             </a:pPr>
             <a:r>
@@ -4922,7 +4708,7 @@
           <a:bodyPr wrap="square" lIns="0" tIns="0" rIns="0" bIns="0" rtlCol="0" anchor="ctr"/>
           <a:lstStyle/>
           <a:p>
-            <a:pPr indent="0" marL="0">
+            <a:pPr marL="0" indent="0">
               <a:buNone/>
             </a:pPr>
             <a:r>
@@ -5006,7 +4792,7 @@
           <a:bodyPr wrap="square" lIns="0" tIns="0" rIns="0" bIns="0" rtlCol="0" anchor="ctr"/>
           <a:lstStyle/>
           <a:p>
-            <a:pPr algn="ctr" indent="0" marL="0">
+            <a:pPr marL="0" indent="0" algn="ctr">
               <a:buNone/>
             </a:pPr>
             <a:r>
@@ -5045,7 +4831,7 @@
           <a:bodyPr wrap="square" lIns="0" tIns="0" rIns="0" bIns="0" rtlCol="0" anchor="ctr"/>
           <a:lstStyle/>
           <a:p>
-            <a:pPr indent="0" marL="0">
+            <a:pPr marL="0" indent="0">
               <a:buNone/>
             </a:pPr>
             <a:r>
@@ -5084,7 +4870,7 @@
           <a:bodyPr wrap="square" lIns="0" tIns="0" rIns="0" bIns="0" rtlCol="0" anchor="ctr"/>
           <a:lstStyle/>
           <a:p>
-            <a:pPr indent="0" marL="0">
+            <a:pPr marL="0" indent="0">
               <a:buNone/>
             </a:pPr>
             <a:r>
@@ -5123,7 +4909,7 @@
           <a:bodyPr wrap="square" lIns="0" tIns="0" rIns="0" bIns="0" rtlCol="0" anchor="ctr"/>
           <a:lstStyle/>
           <a:p>
-            <a:pPr indent="0" marL="0">
+            <a:pPr marL="0" indent="0">
               <a:buNone/>
             </a:pPr>
             <a:r>
@@ -5562,7 +5348,7 @@
           <a:bodyPr wrap="square" lIns="0" tIns="0" rIns="0" bIns="0" rtlCol="0" anchor="ctr"/>
           <a:lstStyle/>
           <a:p>
-            <a:pPr indent="0" marL="0">
+            <a:pPr marL="0" indent="0">
               <a:buNone/>
             </a:pPr>
             <a:r>
@@ -5601,7 +5387,7 @@
           <a:bodyPr wrap="square" lIns="0" tIns="0" rIns="0" bIns="0" rtlCol="0" anchor="ctr"/>
           <a:lstStyle/>
           <a:p>
-            <a:pPr indent="0" marL="0">
+            <a:pPr marL="0" indent="0">
               <a:buNone/>
             </a:pPr>
             <a:r>
@@ -6040,7 +5826,7 @@
           <a:bodyPr wrap="square" lIns="0" tIns="0" rIns="0" bIns="0" rtlCol="0" anchor="ctr"/>
           <a:lstStyle/>
           <a:p>
-            <a:pPr indent="0" marL="0">
+            <a:pPr marL="0" indent="0">
               <a:buNone/>
             </a:pPr>
             <a:r>
@@ -6103,7 +5889,7 @@
           <a:bodyPr wrap="square" lIns="0" tIns="0" rIns="0" bIns="0" rtlCol="0" anchor="ctr"/>
           <a:lstStyle/>
           <a:p>
-            <a:pPr algn="ctr" indent="0" marL="0">
+            <a:pPr marL="0" indent="0" algn="ctr">
               <a:buNone/>
             </a:pPr>
             <a:r>
@@ -6260,7 +6046,7 @@
           <a:bodyPr wrap="square" lIns="0" tIns="0" rIns="0" bIns="0" rtlCol="0" anchor="t"/>
           <a:lstStyle/>
           <a:p>
-            <a:pPr indent="0" marL="0">
+            <a:pPr marL="0" indent="0">
               <a:buNone/>
             </a:pPr>
             <a:r>
@@ -6344,7 +6130,7 @@
           <a:bodyPr wrap="square" lIns="0" tIns="0" rIns="0" bIns="0" rtlCol="0" anchor="ctr"/>
           <a:lstStyle/>
           <a:p>
-            <a:pPr algn="ctr" indent="0" marL="0">
+            <a:pPr marL="0" indent="0" algn="ctr">
               <a:buNone/>
             </a:pPr>
             <a:r>
@@ -6383,7 +6169,7 @@
           <a:bodyPr wrap="square" lIns="0" tIns="0" rIns="0" bIns="0" rtlCol="0" anchor="ctr"/>
           <a:lstStyle/>
           <a:p>
-            <a:pPr indent="0" marL="0">
+            <a:pPr marL="0" indent="0">
               <a:buNone/>
             </a:pPr>
             <a:r>
@@ -6422,7 +6208,7 @@
           <a:bodyPr wrap="square" lIns="0" tIns="0" rIns="0" bIns="0" rtlCol="0" anchor="ctr"/>
           <a:lstStyle/>
           <a:p>
-            <a:pPr indent="0" marL="0">
+            <a:pPr marL="0" indent="0">
               <a:buNone/>
             </a:pPr>
             <a:r>
@@ -6442,14 +6228,14 @@
       </p:sp>
       <p:pic>
         <p:nvPicPr>
-          <p:cNvPr id="6" name="Image 0" descr="C:/Users/hrt_i/Monash/Fit3143/fit3143-lab1/graphs/graph1_runtime_vs_n_pthread.png">    </p:cNvPr>
+          <p:cNvPr id="6" name="Image 0" descr="C:/Users/hrt_i/Monash/Fit3143/fit3143-lab1/graphs/graph1_runtime_vs_n_pthread.png"/>
           <p:cNvPicPr>
             <a:picLocks noChangeAspect="1"/>
           </p:cNvPicPr>
           <p:nvPr/>
         </p:nvPicPr>
         <p:blipFill>
-          <a:blip r:embed="rId1"/>
+          <a:blip r:embed="rId3"/>
           <a:stretch>
             <a:fillRect/>
           </a:stretch>
@@ -6466,14 +6252,14 @@
       </p:pic>
       <p:pic>
         <p:nvPicPr>
-          <p:cNvPr id="7" name="Image 1" descr="C:/Users/hrt_i/Monash/Fit3143/fit3143-lab1/graphs/graph2_speedup_vs_n_pthread.png">    </p:cNvPr>
+          <p:cNvPr id="7" name="Image 1" descr="C:/Users/hrt_i/Monash/Fit3143/fit3143-lab1/graphs/graph2_speedup_vs_n_pthread.png"/>
           <p:cNvPicPr>
             <a:picLocks noChangeAspect="1"/>
           </p:cNvPicPr>
           <p:nvPr/>
         </p:nvPicPr>
         <p:blipFill>
-          <a:blip r:embed="rId2"/>
+          <a:blip r:embed="rId4"/>
           <a:stretch>
             <a:fillRect/>
           </a:stretch>
@@ -6509,7 +6295,7 @@
           <a:bodyPr wrap="square" lIns="0" tIns="0" rIns="0" bIns="0" rtlCol="0" anchor="t"/>
           <a:lstStyle/>
           <a:p>
-            <a:pPr indent="0" marL="0">
+            <a:pPr marL="0" indent="0">
               <a:buNone/>
             </a:pPr>
             <a:r>
@@ -6593,7 +6379,7 @@
           <a:bodyPr wrap="square" lIns="0" tIns="0" rIns="0" bIns="0" rtlCol="0" anchor="ctr"/>
           <a:lstStyle/>
           <a:p>
-            <a:pPr algn="ctr" indent="0" marL="0">
+            <a:pPr marL="0" indent="0" algn="ctr">
               <a:buNone/>
             </a:pPr>
             <a:r>
@@ -6632,7 +6418,7 @@
           <a:bodyPr wrap="square" lIns="0" tIns="0" rIns="0" bIns="0" rtlCol="0" anchor="ctr"/>
           <a:lstStyle/>
           <a:p>
-            <a:pPr indent="0" marL="0">
+            <a:pPr marL="0" indent="0">
               <a:buNone/>
             </a:pPr>
             <a:r>
@@ -6671,7 +6457,7 @@
           <a:bodyPr wrap="square" lIns="0" tIns="0" rIns="0" bIns="0" rtlCol="0" anchor="ctr"/>
           <a:lstStyle/>
           <a:p>
-            <a:pPr indent="0" marL="0">
+            <a:pPr marL="0" indent="0">
               <a:buNone/>
             </a:pPr>
             <a:r>
@@ -6691,14 +6477,14 @@
       </p:sp>
       <p:pic>
         <p:nvPicPr>
-          <p:cNvPr id="6" name="Image 0" descr="C:/Users/hrt_i/Monash/Fit3143/fit3143-lab1/graphs/graph3_runtime_vs_threads_pthread.png">    </p:cNvPr>
+          <p:cNvPr id="6" name="Image 0" descr="C:/Users/hrt_i/Monash/Fit3143/fit3143-lab1/graphs/graph3_runtime_vs_threads_pthread.png"/>
           <p:cNvPicPr>
             <a:picLocks noChangeAspect="1"/>
           </p:cNvPicPr>
           <p:nvPr/>
         </p:nvPicPr>
         <p:blipFill>
-          <a:blip r:embed="rId1"/>
+          <a:blip r:embed="rId3"/>
           <a:stretch>
             <a:fillRect/>
           </a:stretch>
@@ -6715,14 +6501,14 @@
       </p:pic>
       <p:pic>
         <p:nvPicPr>
-          <p:cNvPr id="7" name="Image 1" descr="C:/Users/hrt_i/Monash/Fit3143/fit3143-lab1/graphs/graph4_speedup_vs_threads_pthread.png">    </p:cNvPr>
+          <p:cNvPr id="7" name="Image 1" descr="C:/Users/hrt_i/Monash/Fit3143/fit3143-lab1/graphs/graph4_speedup_vs_threads_pthread.png"/>
           <p:cNvPicPr>
             <a:picLocks noChangeAspect="1"/>
           </p:cNvPicPr>
           <p:nvPr/>
         </p:nvPicPr>
         <p:blipFill>
-          <a:blip r:embed="rId2"/>
+          <a:blip r:embed="rId4"/>
           <a:stretch>
             <a:fillRect/>
           </a:stretch>
@@ -6758,7 +6544,7 @@
           <a:bodyPr wrap="square" lIns="0" tIns="0" rIns="0" bIns="0" rtlCol="0" anchor="t"/>
           <a:lstStyle/>
           <a:p>
-            <a:pPr indent="0" marL="0">
+            <a:pPr marL="0" indent="0">
               <a:buNone/>
             </a:pPr>
             <a:r>
@@ -6775,7 +6561,7 @@
             <a:endParaRPr lang="en-US" sz="1300" dirty="0"/>
           </a:p>
           <a:p>
-            <a:pPr indent="0" marL="0">
+            <a:pPr marL="0" indent="0">
               <a:spcBef>
                 <a:spcPts val="600"/>
               </a:spcBef>
@@ -6862,7 +6648,7 @@
           <a:bodyPr wrap="square" lIns="0" tIns="0" rIns="0" bIns="0" rtlCol="0" anchor="ctr"/>
           <a:lstStyle/>
           <a:p>
-            <a:pPr algn="ctr" indent="0" marL="0">
+            <a:pPr marL="0" indent="0" algn="ctr">
               <a:buNone/>
             </a:pPr>
             <a:r>
@@ -6901,7 +6687,7 @@
           <a:bodyPr wrap="square" lIns="0" tIns="0" rIns="0" bIns="0" rtlCol="0" anchor="ctr"/>
           <a:lstStyle/>
           <a:p>
-            <a:pPr indent="0" marL="0">
+            <a:pPr marL="0" indent="0">
               <a:buNone/>
             </a:pPr>
             <a:r>
@@ -6940,7 +6726,7 @@
           <a:bodyPr wrap="square" lIns="0" tIns="0" rIns="0" bIns="0" rtlCol="0" anchor="ctr"/>
           <a:lstStyle/>
           <a:p>
-            <a:pPr indent="0" marL="0">
+            <a:pPr marL="0" indent="0">
               <a:buNone/>
             </a:pPr>
             <a:r>
@@ -6981,10 +6767,34 @@
             <a:tbl>
               <a:tblPr/>
               <a:tblGrid>
-                <a:gridCol w="1554480"/>
-                <a:gridCol w="1280160"/>
-                <a:gridCol w="1188720"/>
-                <a:gridCol w="1463040"/>
+                <a:gridCol w="1554480">
+                  <a:extLst>
+                    <a:ext uri="{9D8B030D-6E8A-4147-A177-3AD203B41FA5}">
+                      <a16:colId xmlns:a16="http://schemas.microsoft.com/office/drawing/2014/main" val="20000"/>
+                    </a:ext>
+                  </a:extLst>
+                </a:gridCol>
+                <a:gridCol w="1280160">
+                  <a:extLst>
+                    <a:ext uri="{9D8B030D-6E8A-4147-A177-3AD203B41FA5}">
+                      <a16:colId xmlns:a16="http://schemas.microsoft.com/office/drawing/2014/main" val="20001"/>
+                    </a:ext>
+                  </a:extLst>
+                </a:gridCol>
+                <a:gridCol w="1188720">
+                  <a:extLst>
+                    <a:ext uri="{9D8B030D-6E8A-4147-A177-3AD203B41FA5}">
+                      <a16:colId xmlns:a16="http://schemas.microsoft.com/office/drawing/2014/main" val="20002"/>
+                    </a:ext>
+                  </a:extLst>
+                </a:gridCol>
+                <a:gridCol w="1463040">
+                  <a:extLst>
+                    <a:ext uri="{9D8B030D-6E8A-4147-A177-3AD203B41FA5}">
+                      <a16:colId xmlns:a16="http://schemas.microsoft.com/office/drawing/2014/main" val="20003"/>
+                    </a:ext>
+                  </a:extLst>
+                </a:gridCol>
               </a:tblGrid>
               <a:tr h="384048">
                 <a:tc>
@@ -6992,7 +6802,7 @@
                     <a:bodyPr/>
                     <a:lstStyle/>
                     <a:p>
-                      <a:pPr algn="ctr" indent="0" marL="0">
+                      <a:pPr marL="0" indent="0" algn="ctr">
                         <a:buNone/>
                       </a:pPr>
                       <a:r>
@@ -7013,7 +6823,7 @@
                       </a:endParaRPr>
                     </a:p>
                   </a:txBody>
-                  <a:tcPr marL="91440" marR="91440" marT="45720" marB="45720" anchor="ctr">
+                  <a:tcPr anchor="ctr">
                     <a:lnL w="12700" cap="flat" cmpd="sng" algn="ctr">
                       <a:solidFill>
                         <a:srgbClr val="E3E7E9"/>
@@ -7060,7 +6870,7 @@
                     <a:bodyPr/>
                     <a:lstStyle/>
                     <a:p>
-                      <a:pPr algn="ctr" indent="0" marL="0">
+                      <a:pPr marL="0" indent="0" algn="ctr">
                         <a:buNone/>
                       </a:pPr>
                       <a:r>
@@ -7081,7 +6891,7 @@
                       </a:endParaRPr>
                     </a:p>
                   </a:txBody>
-                  <a:tcPr marL="91440" marR="91440" marT="45720" marB="45720" anchor="ctr">
+                  <a:tcPr anchor="ctr">
                     <a:lnL w="12700" cap="flat" cmpd="sng" algn="ctr">
                       <a:solidFill>
                         <a:srgbClr val="E3E7E9"/>
@@ -7128,7 +6938,7 @@
                     <a:bodyPr/>
                     <a:lstStyle/>
                     <a:p>
-                      <a:pPr algn="ctr" indent="0" marL="0">
+                      <a:pPr marL="0" indent="0" algn="ctr">
                         <a:buNone/>
                       </a:pPr>
                       <a:r>
@@ -7149,7 +6959,7 @@
                       </a:endParaRPr>
                     </a:p>
                   </a:txBody>
-                  <a:tcPr marL="91440" marR="91440" marT="45720" marB="45720" anchor="ctr">
+                  <a:tcPr anchor="ctr">
                     <a:lnL w="12700" cap="flat" cmpd="sng" algn="ctr">
                       <a:solidFill>
                         <a:srgbClr val="E3E7E9"/>
@@ -7196,7 +7006,7 @@
                     <a:bodyPr/>
                     <a:lstStyle/>
                     <a:p>
-                      <a:pPr algn="ctr" indent="0" marL="0">
+                      <a:pPr marL="0" indent="0" algn="ctr">
                         <a:buNone/>
                       </a:pPr>
                       <a:r>
@@ -7217,7 +7027,7 @@
                       </a:endParaRPr>
                     </a:p>
                   </a:txBody>
-                  <a:tcPr marL="91440" marR="91440" marT="45720" marB="45720" anchor="ctr">
+                  <a:tcPr anchor="ctr">
                     <a:lnL w="12700" cap="flat" cmpd="sng" algn="ctr">
                       <a:solidFill>
                         <a:srgbClr val="E3E7E9"/>
@@ -7259,6 +7069,11 @@
                     </a:solidFill>
                   </a:tcPr>
                 </a:tc>
+                <a:extLst>
+                  <a:ext uri="{0D108BD9-81ED-4DB2-BD59-A6C34878D82A}">
+                    <a16:rowId xmlns:a16="http://schemas.microsoft.com/office/drawing/2014/main" val="10000"/>
+                  </a:ext>
+                </a:extLst>
               </a:tr>
               <a:tr h="384048">
                 <a:tc>
@@ -7266,7 +7081,7 @@
                     <a:bodyPr/>
                     <a:lstStyle/>
                     <a:p>
-                      <a:pPr algn="ctr" indent="0" marL="0">
+                      <a:pPr marL="0" indent="0" algn="ctr">
                         <a:buNone/>
                       </a:pPr>
                       <a:r>
@@ -7287,7 +7102,7 @@
                       </a:endParaRPr>
                     </a:p>
                   </a:txBody>
-                  <a:tcPr marL="91440" marR="91440" marT="45720" marB="45720" anchor="ctr">
+                  <a:tcPr anchor="ctr">
                     <a:lnL w="12700" cap="flat" cmpd="sng" algn="ctr">
                       <a:solidFill>
                         <a:srgbClr val="E3E7E9"/>
@@ -7334,7 +7149,7 @@
                     <a:bodyPr/>
                     <a:lstStyle/>
                     <a:p>
-                      <a:pPr algn="ctr" indent="0" marL="0">
+                      <a:pPr marL="0" indent="0" algn="ctr">
                         <a:buNone/>
                       </a:pPr>
                       <a:r>
@@ -7355,7 +7170,7 @@
                       </a:endParaRPr>
                     </a:p>
                   </a:txBody>
-                  <a:tcPr marL="91440" marR="91440" marT="45720" marB="45720" anchor="ctr">
+                  <a:tcPr anchor="ctr">
                     <a:lnL w="12700" cap="flat" cmpd="sng" algn="ctr">
                       <a:solidFill>
                         <a:srgbClr val="E3E7E9"/>
@@ -7402,7 +7217,7 @@
                     <a:bodyPr/>
                     <a:lstStyle/>
                     <a:p>
-                      <a:pPr algn="ctr" indent="0" marL="0">
+                      <a:pPr marL="0" indent="0" algn="ctr">
                         <a:buNone/>
                       </a:pPr>
                       <a:r>
@@ -7423,7 +7238,7 @@
                       </a:endParaRPr>
                     </a:p>
                   </a:txBody>
-                  <a:tcPr marL="91440" marR="91440" marT="45720" marB="45720" anchor="ctr">
+                  <a:tcPr anchor="ctr">
                     <a:lnL w="12700" cap="flat" cmpd="sng" algn="ctr">
                       <a:solidFill>
                         <a:srgbClr val="E3E7E9"/>
@@ -7470,7 +7285,7 @@
                     <a:bodyPr/>
                     <a:lstStyle/>
                     <a:p>
-                      <a:pPr algn="ctr" indent="0" marL="0">
+                      <a:pPr marL="0" indent="0" algn="ctr">
                         <a:buNone/>
                       </a:pPr>
                       <a:r>
@@ -7491,7 +7306,7 @@
                       </a:endParaRPr>
                     </a:p>
                   </a:txBody>
-                  <a:tcPr marL="91440" marR="91440" marT="45720" marB="45720" anchor="ctr">
+                  <a:tcPr anchor="ctr">
                     <a:lnL w="12700" cap="flat" cmpd="sng" algn="ctr">
                       <a:solidFill>
                         <a:srgbClr val="E3E7E9"/>
@@ -7533,6 +7348,11 @@
                     </a:solidFill>
                   </a:tcPr>
                 </a:tc>
+                <a:extLst>
+                  <a:ext uri="{0D108BD9-81ED-4DB2-BD59-A6C34878D82A}">
+                    <a16:rowId xmlns:a16="http://schemas.microsoft.com/office/drawing/2014/main" val="10001"/>
+                  </a:ext>
+                </a:extLst>
               </a:tr>
               <a:tr h="384048">
                 <a:tc>
@@ -7540,7 +7360,7 @@
                     <a:bodyPr/>
                     <a:lstStyle/>
                     <a:p>
-                      <a:pPr algn="ctr" indent="0" marL="0">
+                      <a:pPr marL="0" indent="0" algn="ctr">
                         <a:buNone/>
                       </a:pPr>
                       <a:r>
@@ -7561,7 +7381,7 @@
                       </a:endParaRPr>
                     </a:p>
                   </a:txBody>
-                  <a:tcPr marL="91440" marR="91440" marT="45720" marB="45720" anchor="ctr">
+                  <a:tcPr anchor="ctr">
                     <a:lnL w="12700" cap="flat" cmpd="sng" algn="ctr">
                       <a:solidFill>
                         <a:srgbClr val="E3E7E9"/>
@@ -7608,7 +7428,7 @@
                     <a:bodyPr/>
                     <a:lstStyle/>
                     <a:p>
-                      <a:pPr algn="ctr" indent="0" marL="0">
+                      <a:pPr marL="0" indent="0" algn="ctr">
                         <a:buNone/>
                       </a:pPr>
                       <a:r>
@@ -7629,7 +7449,7 @@
                       </a:endParaRPr>
                     </a:p>
                   </a:txBody>
-                  <a:tcPr marL="91440" marR="91440" marT="45720" marB="45720" anchor="ctr">
+                  <a:tcPr anchor="ctr">
                     <a:lnL w="12700" cap="flat" cmpd="sng" algn="ctr">
                       <a:solidFill>
                         <a:srgbClr val="E3E7E9"/>
@@ -7676,7 +7496,7 @@
                     <a:bodyPr/>
                     <a:lstStyle/>
                     <a:p>
-                      <a:pPr algn="ctr" indent="0" marL="0">
+                      <a:pPr marL="0" indent="0" algn="ctr">
                         <a:buNone/>
                       </a:pPr>
                       <a:r>
@@ -7697,7 +7517,7 @@
                       </a:endParaRPr>
                     </a:p>
                   </a:txBody>
-                  <a:tcPr marL="91440" marR="91440" marT="45720" marB="45720" anchor="ctr">
+                  <a:tcPr anchor="ctr">
                     <a:lnL w="12700" cap="flat" cmpd="sng" algn="ctr">
                       <a:solidFill>
                         <a:srgbClr val="E3E7E9"/>
@@ -7744,7 +7564,7 @@
                     <a:bodyPr/>
                     <a:lstStyle/>
                     <a:p>
-                      <a:pPr algn="ctr" indent="0" marL="0">
+                      <a:pPr marL="0" indent="0" algn="ctr">
                         <a:buNone/>
                       </a:pPr>
                       <a:r>
@@ -7765,7 +7585,7 @@
                       </a:endParaRPr>
                     </a:p>
                   </a:txBody>
-                  <a:tcPr marL="91440" marR="91440" marT="45720" marB="45720" anchor="ctr">
+                  <a:tcPr anchor="ctr">
                     <a:lnL w="12700" cap="flat" cmpd="sng" algn="ctr">
                       <a:solidFill>
                         <a:srgbClr val="E3E7E9"/>
@@ -7807,6 +7627,11 @@
                     </a:solidFill>
                   </a:tcPr>
                 </a:tc>
+                <a:extLst>
+                  <a:ext uri="{0D108BD9-81ED-4DB2-BD59-A6C34878D82A}">
+                    <a16:rowId xmlns:a16="http://schemas.microsoft.com/office/drawing/2014/main" val="10002"/>
+                  </a:ext>
+                </a:extLst>
               </a:tr>
               <a:tr h="384048">
                 <a:tc>
@@ -7814,7 +7639,7 @@
                     <a:bodyPr/>
                     <a:lstStyle/>
                     <a:p>
-                      <a:pPr algn="ctr" indent="0" marL="0">
+                      <a:pPr marL="0" indent="0" algn="ctr">
                         <a:buNone/>
                       </a:pPr>
                       <a:r>
@@ -7835,7 +7660,7 @@
                       </a:endParaRPr>
                     </a:p>
                   </a:txBody>
-                  <a:tcPr marL="91440" marR="91440" marT="45720" marB="45720" anchor="ctr">
+                  <a:tcPr anchor="ctr">
                     <a:lnL w="12700" cap="flat" cmpd="sng" algn="ctr">
                       <a:solidFill>
                         <a:srgbClr val="E3E7E9"/>
@@ -7882,7 +7707,7 @@
                     <a:bodyPr/>
                     <a:lstStyle/>
                     <a:p>
-                      <a:pPr algn="ctr" indent="0" marL="0">
+                      <a:pPr marL="0" indent="0" algn="ctr">
                         <a:buNone/>
                       </a:pPr>
                       <a:r>
@@ -7903,7 +7728,7 @@
                       </a:endParaRPr>
                     </a:p>
                   </a:txBody>
-                  <a:tcPr marL="91440" marR="91440" marT="45720" marB="45720" anchor="ctr">
+                  <a:tcPr anchor="ctr">
                     <a:lnL w="12700" cap="flat" cmpd="sng" algn="ctr">
                       <a:solidFill>
                         <a:srgbClr val="E3E7E9"/>
@@ -7950,7 +7775,7 @@
                     <a:bodyPr/>
                     <a:lstStyle/>
                     <a:p>
-                      <a:pPr algn="ctr" indent="0" marL="0">
+                      <a:pPr marL="0" indent="0" algn="ctr">
                         <a:buNone/>
                       </a:pPr>
                       <a:r>
@@ -7971,7 +7796,7 @@
                       </a:endParaRPr>
                     </a:p>
                   </a:txBody>
-                  <a:tcPr marL="91440" marR="91440" marT="45720" marB="45720" anchor="ctr">
+                  <a:tcPr anchor="ctr">
                     <a:lnL w="12700" cap="flat" cmpd="sng" algn="ctr">
                       <a:solidFill>
                         <a:srgbClr val="E3E7E9"/>
@@ -8018,7 +7843,7 @@
                     <a:bodyPr/>
                     <a:lstStyle/>
                     <a:p>
-                      <a:pPr algn="ctr" indent="0" marL="0">
+                      <a:pPr marL="0" indent="0" algn="ctr">
                         <a:buNone/>
                       </a:pPr>
                       <a:r>
@@ -8039,7 +7864,7 @@
                       </a:endParaRPr>
                     </a:p>
                   </a:txBody>
-                  <a:tcPr marL="91440" marR="91440" marT="45720" marB="45720" anchor="ctr">
+                  <a:tcPr anchor="ctr">
                     <a:lnL w="12700" cap="flat" cmpd="sng" algn="ctr">
                       <a:solidFill>
                         <a:srgbClr val="E3E7E9"/>
@@ -8081,6 +7906,11 @@
                     </a:solidFill>
                   </a:tcPr>
                 </a:tc>
+                <a:extLst>
+                  <a:ext uri="{0D108BD9-81ED-4DB2-BD59-A6C34878D82A}">
+                    <a16:rowId xmlns:a16="http://schemas.microsoft.com/office/drawing/2014/main" val="10003"/>
+                  </a:ext>
+                </a:extLst>
               </a:tr>
               <a:tr h="384048">
                 <a:tc>
@@ -8088,7 +7918,7 @@
                     <a:bodyPr/>
                     <a:lstStyle/>
                     <a:p>
-                      <a:pPr algn="ctr" indent="0" marL="0">
+                      <a:pPr marL="0" indent="0" algn="ctr">
                         <a:buNone/>
                       </a:pPr>
                       <a:r>
@@ -8109,7 +7939,7 @@
                       </a:endParaRPr>
                     </a:p>
                   </a:txBody>
-                  <a:tcPr marL="91440" marR="91440" marT="45720" marB="45720" anchor="ctr">
+                  <a:tcPr anchor="ctr">
                     <a:lnL w="12700" cap="flat" cmpd="sng" algn="ctr">
                       <a:solidFill>
                         <a:srgbClr val="E3E7E9"/>
@@ -8156,7 +7986,7 @@
                     <a:bodyPr/>
                     <a:lstStyle/>
                     <a:p>
-                      <a:pPr algn="ctr" indent="0" marL="0">
+                      <a:pPr marL="0" indent="0" algn="ctr">
                         <a:buNone/>
                       </a:pPr>
                       <a:r>
@@ -8177,7 +8007,7 @@
                       </a:endParaRPr>
                     </a:p>
                   </a:txBody>
-                  <a:tcPr marL="91440" marR="91440" marT="45720" marB="45720" anchor="ctr">
+                  <a:tcPr anchor="ctr">
                     <a:lnL w="12700" cap="flat" cmpd="sng" algn="ctr">
                       <a:solidFill>
                         <a:srgbClr val="E3E7E9"/>
@@ -8224,7 +8054,7 @@
                     <a:bodyPr/>
                     <a:lstStyle/>
                     <a:p>
-                      <a:pPr algn="ctr" indent="0" marL="0">
+                      <a:pPr marL="0" indent="0" algn="ctr">
                         <a:buNone/>
                       </a:pPr>
                       <a:r>
@@ -8245,7 +8075,7 @@
                       </a:endParaRPr>
                     </a:p>
                   </a:txBody>
-                  <a:tcPr marL="91440" marR="91440" marT="45720" marB="45720" anchor="ctr">
+                  <a:tcPr anchor="ctr">
                     <a:lnL w="12700" cap="flat" cmpd="sng" algn="ctr">
                       <a:solidFill>
                         <a:srgbClr val="E3E7E9"/>
@@ -8292,7 +8122,7 @@
                     <a:bodyPr/>
                     <a:lstStyle/>
                     <a:p>
-                      <a:pPr algn="ctr" indent="0" marL="0">
+                      <a:pPr marL="0" indent="0" algn="ctr">
                         <a:buNone/>
                       </a:pPr>
                       <a:r>
@@ -8313,7 +8143,7 @@
                       </a:endParaRPr>
                     </a:p>
                   </a:txBody>
-                  <a:tcPr marL="91440" marR="91440" marT="45720" marB="45720" anchor="ctr">
+                  <a:tcPr anchor="ctr">
                     <a:lnL w="12700" cap="flat" cmpd="sng" algn="ctr">
                       <a:solidFill>
                         <a:srgbClr val="E3E7E9"/>
@@ -8355,6 +8185,11 @@
                     </a:solidFill>
                   </a:tcPr>
                 </a:tc>
+                <a:extLst>
+                  <a:ext uri="{0D108BD9-81ED-4DB2-BD59-A6C34878D82A}">
+                    <a16:rowId xmlns:a16="http://schemas.microsoft.com/office/drawing/2014/main" val="10004"/>
+                  </a:ext>
+                </a:extLst>
               </a:tr>
             </a:tbl>
           </a:graphicData>
@@ -8381,7 +8216,7 @@
           <a:bodyPr wrap="square" lIns="0" tIns="0" rIns="0" bIns="0" rtlCol="0" anchor="ctr"/>
           <a:lstStyle/>
           <a:p>
-            <a:pPr indent="0" marL="0">
+            <a:pPr marL="0" indent="0">
               <a:buNone/>
             </a:pPr>
             <a:r>
@@ -8401,7 +8236,7 @@
       </p:sp>
       <p:sp>
         <p:nvSpPr>
-          <p:cNvPr id="8" name="Text 5"/>
+          <p:cNvPr id="6" name="Text 5"/>
           <p:cNvSpPr/>
           <p:nvPr/>
         </p:nvSpPr>
@@ -8420,7 +8255,7 @@
           <a:bodyPr wrap="square" lIns="0" tIns="0" rIns="0" bIns="0" rtlCol="0" anchor="ctr"/>
           <a:lstStyle/>
           <a:p>
-            <a:pPr indent="0" marL="0">
+            <a:pPr marL="0" indent="0">
               <a:buNone/>
             </a:pPr>
             <a:r>
@@ -8604,7 +8439,7 @@
           <a:bodyPr wrap="square" lIns="0" tIns="0" rIns="0" bIns="0" rtlCol="0" anchor="ctr"/>
           <a:lstStyle/>
           <a:p>
-            <a:pPr indent="0" marL="0">
+            <a:pPr marL="0" indent="0">
               <a:buNone/>
             </a:pPr>
             <a:r>
@@ -8643,7 +8478,7 @@
           <a:bodyPr wrap="square" lIns="0" tIns="0" rIns="0" bIns="0" rtlCol="0" anchor="t"/>
           <a:lstStyle/>
           <a:p>
-            <a:pPr indent="0" marL="0">
+            <a:pPr marL="0" indent="0">
               <a:buNone/>
             </a:pPr>
             <a:r>
@@ -8727,7 +8562,7 @@
           <a:bodyPr wrap="square" lIns="0" tIns="0" rIns="0" bIns="0" rtlCol="0" anchor="ctr"/>
           <a:lstStyle/>
           <a:p>
-            <a:pPr algn="ctr" indent="0" marL="0">
+            <a:pPr marL="0" indent="0" algn="ctr">
               <a:buNone/>
             </a:pPr>
             <a:r>
@@ -8766,7 +8601,7 @@
           <a:bodyPr wrap="square" lIns="0" tIns="0" rIns="0" bIns="0" rtlCol="0" anchor="ctr"/>
           <a:lstStyle/>
           <a:p>
-            <a:pPr indent="0" marL="0">
+            <a:pPr marL="0" indent="0">
               <a:buNone/>
             </a:pPr>
             <a:r>
@@ -8805,7 +8640,7 @@
           <a:bodyPr wrap="square" lIns="0" tIns="0" rIns="0" bIns="0" rtlCol="0" anchor="ctr"/>
           <a:lstStyle/>
           <a:p>
-            <a:pPr indent="0" marL="0">
+            <a:pPr marL="0" indent="0">
               <a:buNone/>
             </a:pPr>
             <a:r>
@@ -8871,7 +8706,7 @@
           <a:bodyPr wrap="square" lIns="0" tIns="0" rIns="0" bIns="0" rtlCol="0" anchor="ctr"/>
           <a:lstStyle/>
           <a:p>
-            <a:pPr indent="0" marL="0">
+            <a:pPr marL="0" indent="0">
               <a:buNone/>
             </a:pPr>
             <a:r>
@@ -8910,7 +8745,7 @@
           <a:bodyPr wrap="square" lIns="0" tIns="0" rIns="0" bIns="0" rtlCol="0" anchor="ctr"/>
           <a:lstStyle/>
           <a:p>
-            <a:pPr indent="0" marL="0">
+            <a:pPr marL="0" indent="0">
               <a:buNone/>
             </a:pPr>
             <a:r>
@@ -9024,7 +8859,7 @@
       </p:sp>
       <p:graphicFrame>
         <p:nvGraphicFramePr>
-          <p:cNvPr id="9" name="Table 0"/>
+          <p:cNvPr id="10" name="Table 0"/>
           <p:cNvGraphicFramePr>
             <a:graphicFrameLocks noGrp="1"/>
           </p:cNvGraphicFramePr>
@@ -9045,9 +8880,27 @@
             <a:tbl>
               <a:tblPr/>
               <a:tblGrid>
-                <a:gridCol w="2286000"/>
-                <a:gridCol w="1371600"/>
-                <a:gridCol w="1463040"/>
+                <a:gridCol w="2286000">
+                  <a:extLst>
+                    <a:ext uri="{9D8B030D-6E8A-4147-A177-3AD203B41FA5}">
+                      <a16:colId xmlns:a16="http://schemas.microsoft.com/office/drawing/2014/main" val="20000"/>
+                    </a:ext>
+                  </a:extLst>
+                </a:gridCol>
+                <a:gridCol w="1371600">
+                  <a:extLst>
+                    <a:ext uri="{9D8B030D-6E8A-4147-A177-3AD203B41FA5}">
+                      <a16:colId xmlns:a16="http://schemas.microsoft.com/office/drawing/2014/main" val="20001"/>
+                    </a:ext>
+                  </a:extLst>
+                </a:gridCol>
+                <a:gridCol w="1463040">
+                  <a:extLst>
+                    <a:ext uri="{9D8B030D-6E8A-4147-A177-3AD203B41FA5}">
+                      <a16:colId xmlns:a16="http://schemas.microsoft.com/office/drawing/2014/main" val="20002"/>
+                    </a:ext>
+                  </a:extLst>
+                </a:gridCol>
               </a:tblGrid>
               <a:tr h="384048">
                 <a:tc>
@@ -9055,7 +8908,7 @@
                     <a:bodyPr/>
                     <a:lstStyle/>
                     <a:p>
-                      <a:pPr algn="ctr" indent="0" marL="0">
+                      <a:pPr marL="0" indent="0" algn="ctr">
                         <a:buNone/>
                       </a:pPr>
                       <a:r>
@@ -9076,7 +8929,7 @@
                       </a:endParaRPr>
                     </a:p>
                   </a:txBody>
-                  <a:tcPr marL="91440" marR="91440" marT="45720" marB="45720" anchor="ctr">
+                  <a:tcPr anchor="ctr">
                     <a:lnL w="12700" cap="flat" cmpd="sng" algn="ctr">
                       <a:solidFill>
                         <a:srgbClr val="E3E7E9"/>
@@ -9123,7 +8976,7 @@
                     <a:bodyPr/>
                     <a:lstStyle/>
                     <a:p>
-                      <a:pPr algn="ctr" indent="0" marL="0">
+                      <a:pPr marL="0" indent="0" algn="ctr">
                         <a:buNone/>
                       </a:pPr>
                       <a:r>
@@ -9144,7 +8997,7 @@
                       </a:endParaRPr>
                     </a:p>
                   </a:txBody>
-                  <a:tcPr marL="91440" marR="91440" marT="45720" marB="45720" anchor="ctr">
+                  <a:tcPr anchor="ctr">
                     <a:lnL w="12700" cap="flat" cmpd="sng" algn="ctr">
                       <a:solidFill>
                         <a:srgbClr val="E3E7E9"/>
@@ -9191,7 +9044,7 @@
                     <a:bodyPr/>
                     <a:lstStyle/>
                     <a:p>
-                      <a:pPr algn="ctr" indent="0" marL="0">
+                      <a:pPr marL="0" indent="0" algn="ctr">
                         <a:buNone/>
                       </a:pPr>
                       <a:r>
@@ -9212,7 +9065,7 @@
                       </a:endParaRPr>
                     </a:p>
                   </a:txBody>
-                  <a:tcPr marL="91440" marR="91440" marT="45720" marB="45720" anchor="ctr">
+                  <a:tcPr anchor="ctr">
                     <a:lnL w="12700" cap="flat" cmpd="sng" algn="ctr">
                       <a:solidFill>
                         <a:srgbClr val="E3E7E9"/>
@@ -9254,6 +9107,11 @@
                     </a:solidFill>
                   </a:tcPr>
                 </a:tc>
+                <a:extLst>
+                  <a:ext uri="{0D108BD9-81ED-4DB2-BD59-A6C34878D82A}">
+                    <a16:rowId xmlns:a16="http://schemas.microsoft.com/office/drawing/2014/main" val="10000"/>
+                  </a:ext>
+                </a:extLst>
               </a:tr>
               <a:tr h="384048">
                 <a:tc>
@@ -9261,7 +9119,7 @@
                     <a:bodyPr/>
                     <a:lstStyle/>
                     <a:p>
-                      <a:pPr algn="ctr" indent="0" marL="0">
+                      <a:pPr marL="0" indent="0" algn="ctr">
                         <a:buNone/>
                       </a:pPr>
                       <a:r>
@@ -9282,7 +9140,7 @@
                       </a:endParaRPr>
                     </a:p>
                   </a:txBody>
-                  <a:tcPr marL="91440" marR="91440" marT="45720" marB="45720" anchor="ctr">
+                  <a:tcPr anchor="ctr">
                     <a:lnL w="12700" cap="flat" cmpd="sng" algn="ctr">
                       <a:solidFill>
                         <a:srgbClr val="E3E7E9"/>
@@ -9329,7 +9187,7 @@
                     <a:bodyPr/>
                     <a:lstStyle/>
                     <a:p>
-                      <a:pPr algn="ctr" indent="0" marL="0">
+                      <a:pPr marL="0" indent="0" algn="ctr">
                         <a:buNone/>
                       </a:pPr>
                       <a:r>
@@ -9350,7 +9208,7 @@
                       </a:endParaRPr>
                     </a:p>
                   </a:txBody>
-                  <a:tcPr marL="91440" marR="91440" marT="45720" marB="45720" anchor="ctr">
+                  <a:tcPr anchor="ctr">
                     <a:lnL w="12700" cap="flat" cmpd="sng" algn="ctr">
                       <a:solidFill>
                         <a:srgbClr val="E3E7E9"/>
@@ -9397,7 +9255,7 @@
                     <a:bodyPr/>
                     <a:lstStyle/>
                     <a:p>
-                      <a:pPr algn="ctr" indent="0" marL="0">
+                      <a:pPr marL="0" indent="0" algn="ctr">
                         <a:buNone/>
                       </a:pPr>
                       <a:r>
@@ -9418,7 +9276,7 @@
                       </a:endParaRPr>
                     </a:p>
                   </a:txBody>
-                  <a:tcPr marL="91440" marR="91440" marT="45720" marB="45720" anchor="ctr">
+                  <a:tcPr anchor="ctr">
                     <a:lnL w="12700" cap="flat" cmpd="sng" algn="ctr">
                       <a:solidFill>
                         <a:srgbClr val="E3E7E9"/>
@@ -9460,6 +9318,11 @@
                     </a:solidFill>
                   </a:tcPr>
                 </a:tc>
+                <a:extLst>
+                  <a:ext uri="{0D108BD9-81ED-4DB2-BD59-A6C34878D82A}">
+                    <a16:rowId xmlns:a16="http://schemas.microsoft.com/office/drawing/2014/main" val="10001"/>
+                  </a:ext>
+                </a:extLst>
               </a:tr>
               <a:tr h="384048">
                 <a:tc>
@@ -9467,7 +9330,7 @@
                     <a:bodyPr/>
                     <a:lstStyle/>
                     <a:p>
-                      <a:pPr algn="ctr" indent="0" marL="0">
+                      <a:pPr marL="0" indent="0" algn="ctr">
                         <a:buNone/>
                       </a:pPr>
                       <a:r>
@@ -9488,7 +9351,7 @@
                       </a:endParaRPr>
                     </a:p>
                   </a:txBody>
-                  <a:tcPr marL="91440" marR="91440" marT="45720" marB="45720" anchor="ctr">
+                  <a:tcPr anchor="ctr">
                     <a:lnL w="12700" cap="flat" cmpd="sng" algn="ctr">
                       <a:solidFill>
                         <a:srgbClr val="E3E7E9"/>
@@ -9535,7 +9398,7 @@
                     <a:bodyPr/>
                     <a:lstStyle/>
                     <a:p>
-                      <a:pPr algn="ctr" indent="0" marL="0">
+                      <a:pPr marL="0" indent="0" algn="ctr">
                         <a:buNone/>
                       </a:pPr>
                       <a:r>
@@ -9556,7 +9419,7 @@
                       </a:endParaRPr>
                     </a:p>
                   </a:txBody>
-                  <a:tcPr marL="91440" marR="91440" marT="45720" marB="45720" anchor="ctr">
+                  <a:tcPr anchor="ctr">
                     <a:lnL w="12700" cap="flat" cmpd="sng" algn="ctr">
                       <a:solidFill>
                         <a:srgbClr val="E3E7E9"/>
@@ -9603,7 +9466,7 @@
                     <a:bodyPr/>
                     <a:lstStyle/>
                     <a:p>
-                      <a:pPr algn="ctr" indent="0" marL="0">
+                      <a:pPr marL="0" indent="0" algn="ctr">
                         <a:buNone/>
                       </a:pPr>
                       <a:r>
@@ -9624,7 +9487,7 @@
                       </a:endParaRPr>
                     </a:p>
                   </a:txBody>
-                  <a:tcPr marL="91440" marR="91440" marT="45720" marB="45720" anchor="ctr">
+                  <a:tcPr anchor="ctr">
                     <a:lnL w="12700" cap="flat" cmpd="sng" algn="ctr">
                       <a:solidFill>
                         <a:srgbClr val="E3E7E9"/>
@@ -9666,6 +9529,11 @@
                     </a:solidFill>
                   </a:tcPr>
                 </a:tc>
+                <a:extLst>
+                  <a:ext uri="{0D108BD9-81ED-4DB2-BD59-A6C34878D82A}">
+                    <a16:rowId xmlns:a16="http://schemas.microsoft.com/office/drawing/2014/main" val="10002"/>
+                  </a:ext>
+                </a:extLst>
               </a:tr>
               <a:tr h="384048">
                 <a:tc>
@@ -9673,7 +9541,7 @@
                     <a:bodyPr/>
                     <a:lstStyle/>
                     <a:p>
-                      <a:pPr algn="ctr" indent="0" marL="0">
+                      <a:pPr marL="0" indent="0" algn="ctr">
                         <a:buNone/>
                       </a:pPr>
                       <a:r>
@@ -9694,7 +9562,7 @@
                       </a:endParaRPr>
                     </a:p>
                   </a:txBody>
-                  <a:tcPr marL="91440" marR="91440" marT="45720" marB="45720" anchor="ctr">
+                  <a:tcPr anchor="ctr">
                     <a:lnL w="12700" cap="flat" cmpd="sng" algn="ctr">
                       <a:solidFill>
                         <a:srgbClr val="E3E7E9"/>
@@ -9741,7 +9609,7 @@
                     <a:bodyPr/>
                     <a:lstStyle/>
                     <a:p>
-                      <a:pPr algn="ctr" indent="0" marL="0">
+                      <a:pPr marL="0" indent="0" algn="ctr">
                         <a:buNone/>
                       </a:pPr>
                       <a:r>
@@ -9762,7 +9630,7 @@
                       </a:endParaRPr>
                     </a:p>
                   </a:txBody>
-                  <a:tcPr marL="91440" marR="91440" marT="45720" marB="45720" anchor="ctr">
+                  <a:tcPr anchor="ctr">
                     <a:lnL w="12700" cap="flat" cmpd="sng" algn="ctr">
                       <a:solidFill>
                         <a:srgbClr val="E3E7E9"/>
@@ -9809,7 +9677,7 @@
                     <a:bodyPr/>
                     <a:lstStyle/>
                     <a:p>
-                      <a:pPr algn="ctr" indent="0" marL="0">
+                      <a:pPr marL="0" indent="0" algn="ctr">
                         <a:buNone/>
                       </a:pPr>
                       <a:r>
@@ -9830,7 +9698,7 @@
                       </a:endParaRPr>
                     </a:p>
                   </a:txBody>
-                  <a:tcPr marL="91440" marR="91440" marT="45720" marB="45720" anchor="ctr">
+                  <a:tcPr anchor="ctr">
                     <a:lnL w="12700" cap="flat" cmpd="sng" algn="ctr">
                       <a:solidFill>
                         <a:srgbClr val="E3E7E9"/>
@@ -9872,6 +9740,11 @@
                     </a:solidFill>
                   </a:tcPr>
                 </a:tc>
+                <a:extLst>
+                  <a:ext uri="{0D108BD9-81ED-4DB2-BD59-A6C34878D82A}">
+                    <a16:rowId xmlns:a16="http://schemas.microsoft.com/office/drawing/2014/main" val="10003"/>
+                  </a:ext>
+                </a:extLst>
               </a:tr>
               <a:tr h="384048">
                 <a:tc>
@@ -9879,7 +9752,7 @@
                     <a:bodyPr/>
                     <a:lstStyle/>
                     <a:p>
-                      <a:pPr algn="ctr" indent="0" marL="0">
+                      <a:pPr marL="0" indent="0" algn="ctr">
                         <a:buNone/>
                       </a:pPr>
                       <a:r>
@@ -9900,7 +9773,7 @@
                       </a:endParaRPr>
                     </a:p>
                   </a:txBody>
-                  <a:tcPr marL="91440" marR="91440" marT="45720" marB="45720" anchor="ctr">
+                  <a:tcPr anchor="ctr">
                     <a:lnL w="12700" cap="flat" cmpd="sng" algn="ctr">
                       <a:solidFill>
                         <a:srgbClr val="E3E7E9"/>
@@ -9947,7 +9820,7 @@
                     <a:bodyPr/>
                     <a:lstStyle/>
                     <a:p>
-                      <a:pPr algn="ctr" indent="0" marL="0">
+                      <a:pPr marL="0" indent="0" algn="ctr">
                         <a:buNone/>
                       </a:pPr>
                       <a:r>
@@ -9968,7 +9841,7 @@
                       </a:endParaRPr>
                     </a:p>
                   </a:txBody>
-                  <a:tcPr marL="91440" marR="91440" marT="45720" marB="45720" anchor="ctr">
+                  <a:tcPr anchor="ctr">
                     <a:lnL w="12700" cap="flat" cmpd="sng" algn="ctr">
                       <a:solidFill>
                         <a:srgbClr val="E3E7E9"/>
@@ -10015,7 +9888,7 @@
                     <a:bodyPr/>
                     <a:lstStyle/>
                     <a:p>
-                      <a:pPr algn="ctr" indent="0" marL="0">
+                      <a:pPr marL="0" indent="0" algn="ctr">
                         <a:buNone/>
                       </a:pPr>
                       <a:r>
@@ -10036,7 +9909,7 @@
                       </a:endParaRPr>
                     </a:p>
                   </a:txBody>
-                  <a:tcPr marL="91440" marR="91440" marT="45720" marB="45720" anchor="ctr">
+                  <a:tcPr anchor="ctr">
                     <a:lnL w="12700" cap="flat" cmpd="sng" algn="ctr">
                       <a:solidFill>
                         <a:srgbClr val="E3E7E9"/>
@@ -10078,6 +9951,11 @@
                     </a:solidFill>
                   </a:tcPr>
                 </a:tc>
+                <a:extLst>
+                  <a:ext uri="{0D108BD9-81ED-4DB2-BD59-A6C34878D82A}">
+                    <a16:rowId xmlns:a16="http://schemas.microsoft.com/office/drawing/2014/main" val="10004"/>
+                  </a:ext>
+                </a:extLst>
               </a:tr>
             </a:tbl>
           </a:graphicData>
@@ -10104,7 +9982,7 @@
           <a:bodyPr wrap="square" lIns="0" tIns="0" rIns="0" bIns="0" rtlCol="0" anchor="ctr"/>
           <a:lstStyle/>
           <a:p>
-            <a:pPr indent="0" marL="0">
+            <a:pPr marL="0" indent="0">
               <a:buNone/>
             </a:pPr>
             <a:r>
@@ -10143,7 +10021,7 @@
           <a:bodyPr wrap="square" lIns="0" tIns="0" rIns="0" bIns="0" rtlCol="0" anchor="t"/>
           <a:lstStyle/>
           <a:p>
-            <a:pPr indent="0" marL="0">
+            <a:pPr marL="0" indent="0">
               <a:buNone/>
             </a:pPr>
             <a:r>
@@ -10227,7 +10105,7 @@
           <a:bodyPr wrap="square" lIns="0" tIns="0" rIns="0" bIns="0" rtlCol="0" anchor="ctr"/>
           <a:lstStyle/>
           <a:p>
-            <a:pPr algn="ctr" indent="0" marL="0">
+            <a:pPr marL="0" indent="0" algn="ctr">
               <a:buNone/>
             </a:pPr>
             <a:r>
@@ -10266,7 +10144,7 @@
           <a:bodyPr wrap="square" lIns="0" tIns="0" rIns="0" bIns="0" rtlCol="0" anchor="ctr"/>
           <a:lstStyle/>
           <a:p>
-            <a:pPr indent="0" marL="0">
+            <a:pPr marL="0" indent="0">
               <a:buNone/>
             </a:pPr>
             <a:r>
@@ -10305,7 +10183,7 @@
           <a:bodyPr wrap="square" lIns="0" tIns="0" rIns="0" bIns="0" rtlCol="0" anchor="ctr"/>
           <a:lstStyle/>
           <a:p>
-            <a:pPr indent="0" marL="0">
+            <a:pPr marL="0" indent="0">
               <a:buNone/>
             </a:pPr>
             <a:r>
@@ -10325,14 +10203,14 @@
       </p:sp>
       <p:pic>
         <p:nvPicPr>
-          <p:cNvPr id="6" name="Image 0" descr="C:/Users/hrt_i/Monash/Fit3143/fit3143-lab1/graphs/graph5_runtime_vs_n_openmp.png">    </p:cNvPr>
+          <p:cNvPr id="6" name="Image 0" descr="C:/Users/hrt_i/Monash/Fit3143/fit3143-lab1/graphs/graph5_runtime_vs_n_openmp.png"/>
           <p:cNvPicPr>
             <a:picLocks noChangeAspect="1"/>
           </p:cNvPicPr>
           <p:nvPr/>
         </p:nvPicPr>
         <p:blipFill>
-          <a:blip r:embed="rId1"/>
+          <a:blip r:embed="rId3"/>
           <a:stretch>
             <a:fillRect/>
           </a:stretch>
@@ -10349,14 +10227,14 @@
       </p:pic>
       <p:pic>
         <p:nvPicPr>
-          <p:cNvPr id="7" name="Image 1" descr="C:/Users/hrt_i/Monash/Fit3143/fit3143-lab1/graphs/graph6_speedup_vs_n_openmp.png">    </p:cNvPr>
+          <p:cNvPr id="7" name="Image 1" descr="C:/Users/hrt_i/Monash/Fit3143/fit3143-lab1/graphs/graph6_speedup_vs_n_openmp.png"/>
           <p:cNvPicPr>
             <a:picLocks noChangeAspect="1"/>
           </p:cNvPicPr>
           <p:nvPr/>
         </p:nvPicPr>
         <p:blipFill>
-          <a:blip r:embed="rId2"/>
+          <a:blip r:embed="rId4"/>
           <a:stretch>
             <a:fillRect/>
           </a:stretch>
@@ -10392,7 +10270,7 @@
           <a:bodyPr wrap="square" lIns="0" tIns="0" rIns="0" bIns="0" rtlCol="0" anchor="t"/>
           <a:lstStyle/>
           <a:p>
-            <a:pPr indent="0" marL="0">
+            <a:pPr marL="0" indent="0">
               <a:buNone/>
             </a:pPr>
             <a:r>
@@ -10711,4 +10589,299 @@
     </a:ext>
   </a:extLst>
 </a:theme>
+</file>
+
+<file path=ppt/theme/theme2.xml><?xml version="1.0" encoding="utf-8"?>
+<a:theme xmlns:a="http://schemas.openxmlformats.org/drawingml/2006/main" name="Office Theme">
+  <a:themeElements>
+    <a:clrScheme name="Office">
+      <a:dk1>
+        <a:sysClr val="windowText" lastClr="000000"/>
+      </a:dk1>
+      <a:lt1>
+        <a:sysClr val="window" lastClr="FFFFFF"/>
+      </a:lt1>
+      <a:dk2>
+        <a:srgbClr val="44546A"/>
+      </a:dk2>
+      <a:lt2>
+        <a:srgbClr val="E7E6E6"/>
+      </a:lt2>
+      <a:accent1>
+        <a:srgbClr val="4472C4"/>
+      </a:accent1>
+      <a:accent2>
+        <a:srgbClr val="ED7D31"/>
+      </a:accent2>
+      <a:accent3>
+        <a:srgbClr val="A5A5A5"/>
+      </a:accent3>
+      <a:accent4>
+        <a:srgbClr val="FFC000"/>
+      </a:accent4>
+      <a:accent5>
+        <a:srgbClr val="5B9BD5"/>
+      </a:accent5>
+      <a:accent6>
+        <a:srgbClr val="70AD47"/>
+      </a:accent6>
+      <a:hlink>
+        <a:srgbClr val="0563C1"/>
+      </a:hlink>
+      <a:folHlink>
+        <a:srgbClr val="954F72"/>
+      </a:folHlink>
+    </a:clrScheme>
+    <a:fontScheme name="Office">
+      <a:majorFont>
+        <a:latin typeface="Calibri Light" panose="020F0302020204030204"/>
+        <a:ea typeface=""/>
+        <a:cs typeface=""/>
+        <a:font script="Jpan" typeface="游ゴシック Light"/>
+        <a:font script="Hang" typeface="맑은 고딕"/>
+        <a:font script="Hans" typeface="等线 Light"/>
+        <a:font script="Hant" typeface="新細明體"/>
+        <a:font script="Arab" typeface="Times New Roman"/>
+        <a:font script="Hebr" typeface="Times New Roman"/>
+        <a:font script="Thai" typeface="Angsana New"/>
+        <a:font script="Ethi" typeface="Nyala"/>
+        <a:font script="Beng" typeface="Vrinda"/>
+        <a:font script="Gujr" typeface="Shruti"/>
+        <a:font script="Khmr" typeface="MoolBoran"/>
+        <a:font script="Knda" typeface="Tunga"/>
+        <a:font script="Guru" typeface="Raavi"/>
+        <a:font script="Cans" typeface="Euphemia"/>
+        <a:font script="Cher" typeface="Plantagenet Cherokee"/>
+        <a:font script="Yiii" typeface="Microsoft Yi Baiti"/>
+        <a:font script="Tibt" typeface="Microsoft Himalaya"/>
+        <a:font script="Thaa" typeface="MV Boli"/>
+        <a:font script="Deva" typeface="Mangal"/>
+        <a:font script="Telu" typeface="Gautami"/>
+        <a:font script="Taml" typeface="Latha"/>
+        <a:font script="Syrc" typeface="Estrangelo Edessa"/>
+        <a:font script="Orya" typeface="Kalinga"/>
+        <a:font script="Mlym" typeface="Kartika"/>
+        <a:font script="Laoo" typeface="DokChampa"/>
+        <a:font script="Sinh" typeface="Iskoola Pota"/>
+        <a:font script="Mong" typeface="Mongolian Baiti"/>
+        <a:font script="Viet" typeface="Times New Roman"/>
+        <a:font script="Uigh" typeface="Microsoft Uighur"/>
+        <a:font script="Geor" typeface="Sylfaen"/>
+        <a:font script="Armn" typeface="Arial"/>
+        <a:font script="Bugi" typeface="Leelawadee UI"/>
+        <a:font script="Bopo" typeface="Microsoft JhengHei"/>
+        <a:font script="Java" typeface="Javanese Text"/>
+        <a:font script="Lisu" typeface="Segoe UI"/>
+        <a:font script="Mymr" typeface="Myanmar Text"/>
+        <a:font script="Nkoo" typeface="Ebrima"/>
+        <a:font script="Olck" typeface="Nirmala UI"/>
+        <a:font script="Osma" typeface="Ebrima"/>
+        <a:font script="Phag" typeface="Phagspa"/>
+        <a:font script="Syrn" typeface="Estrangelo Edessa"/>
+        <a:font script="Syrj" typeface="Estrangelo Edessa"/>
+        <a:font script="Syre" typeface="Estrangelo Edessa"/>
+        <a:font script="Sora" typeface="Nirmala UI"/>
+        <a:font script="Tale" typeface="Microsoft Tai Le"/>
+        <a:font script="Talu" typeface="Microsoft New Tai Lue"/>
+        <a:font script="Tfng" typeface="Ebrima"/>
+      </a:majorFont>
+      <a:minorFont>
+        <a:latin typeface="Calibri" panose="020F0502020204030204"/>
+        <a:ea typeface=""/>
+        <a:cs typeface=""/>
+        <a:font script="Jpan" typeface="游ゴシック"/>
+        <a:font script="Hang" typeface="맑은 고딕"/>
+        <a:font script="Hans" typeface="等线"/>
+        <a:font script="Hant" typeface="新細明體"/>
+        <a:font script="Arab" typeface="Arial"/>
+        <a:font script="Hebr" typeface="Arial"/>
+        <a:font script="Thai" typeface="Cordia New"/>
+        <a:font script="Ethi" typeface="Nyala"/>
+        <a:font script="Beng" typeface="Vrinda"/>
+        <a:font script="Gujr" typeface="Shruti"/>
+        <a:font script="Khmr" typeface="DaunPenh"/>
+        <a:font script="Knda" typeface="Tunga"/>
+        <a:font script="Guru" typeface="Raavi"/>
+        <a:font script="Cans" typeface="Euphemia"/>
+        <a:font script="Cher" typeface="Plantagenet Cherokee"/>
+        <a:font script="Yiii" typeface="Microsoft Yi Baiti"/>
+        <a:font script="Tibt" typeface="Microsoft Himalaya"/>
+        <a:font script="Thaa" typeface="MV Boli"/>
+        <a:font script="Deva" typeface="Mangal"/>
+        <a:font script="Telu" typeface="Gautami"/>
+        <a:font script="Taml" typeface="Latha"/>
+        <a:font script="Syrc" typeface="Estrangelo Edessa"/>
+        <a:font script="Orya" typeface="Kalinga"/>
+        <a:font script="Mlym" typeface="Kartika"/>
+        <a:font script="Laoo" typeface="DokChampa"/>
+        <a:font script="Sinh" typeface="Iskoola Pota"/>
+        <a:font script="Mong" typeface="Mongolian Baiti"/>
+        <a:font script="Viet" typeface="Arial"/>
+        <a:font script="Uigh" typeface="Microsoft Uighur"/>
+        <a:font script="Geor" typeface="Sylfaen"/>
+        <a:font script="Armn" typeface="Arial"/>
+        <a:font script="Bugi" typeface="Leelawadee UI"/>
+        <a:font script="Bopo" typeface="Microsoft JhengHei"/>
+        <a:font script="Java" typeface="Javanese Text"/>
+        <a:font script="Lisu" typeface="Segoe UI"/>
+        <a:font script="Mymr" typeface="Myanmar Text"/>
+        <a:font script="Nkoo" typeface="Ebrima"/>
+        <a:font script="Olck" typeface="Nirmala UI"/>
+        <a:font script="Osma" typeface="Ebrima"/>
+        <a:font script="Phag" typeface="Phagspa"/>
+        <a:font script="Syrn" typeface="Estrangelo Edessa"/>
+        <a:font script="Syrj" typeface="Estrangelo Edessa"/>
+        <a:font script="Syre" typeface="Estrangelo Edessa"/>
+        <a:font script="Sora" typeface="Nirmala UI"/>
+        <a:font script="Tale" typeface="Microsoft Tai Le"/>
+        <a:font script="Talu" typeface="Microsoft New Tai Lue"/>
+        <a:font script="Tfng" typeface="Ebrima"/>
+      </a:minorFont>
+    </a:fontScheme>
+    <a:fmtScheme name="Office">
+      <a:fillStyleLst>
+        <a:solidFill>
+          <a:schemeClr val="phClr"/>
+        </a:solidFill>
+        <a:gradFill rotWithShape="1">
+          <a:gsLst>
+            <a:gs pos="0">
+              <a:schemeClr val="phClr">
+                <a:lumMod val="110000"/>
+                <a:satMod val="105000"/>
+                <a:tint val="67000"/>
+              </a:schemeClr>
+            </a:gs>
+            <a:gs pos="50000">
+              <a:schemeClr val="phClr">
+                <a:lumMod val="105000"/>
+                <a:satMod val="103000"/>
+                <a:tint val="73000"/>
+              </a:schemeClr>
+            </a:gs>
+            <a:gs pos="100000">
+              <a:schemeClr val="phClr">
+                <a:lumMod val="105000"/>
+                <a:satMod val="109000"/>
+                <a:tint val="81000"/>
+              </a:schemeClr>
+            </a:gs>
+          </a:gsLst>
+          <a:lin ang="5400000" scaled="0"/>
+        </a:gradFill>
+        <a:gradFill rotWithShape="1">
+          <a:gsLst>
+            <a:gs pos="0">
+              <a:schemeClr val="phClr">
+                <a:satMod val="103000"/>
+                <a:lumMod val="102000"/>
+                <a:tint val="94000"/>
+              </a:schemeClr>
+            </a:gs>
+            <a:gs pos="50000">
+              <a:schemeClr val="phClr">
+                <a:satMod val="110000"/>
+                <a:lumMod val="100000"/>
+                <a:shade val="100000"/>
+              </a:schemeClr>
+            </a:gs>
+            <a:gs pos="100000">
+              <a:schemeClr val="phClr">
+                <a:lumMod val="99000"/>
+                <a:satMod val="120000"/>
+                <a:shade val="78000"/>
+              </a:schemeClr>
+            </a:gs>
+          </a:gsLst>
+          <a:lin ang="5400000" scaled="0"/>
+        </a:gradFill>
+      </a:fillStyleLst>
+      <a:lnStyleLst>
+        <a:ln w="6350" cap="flat" cmpd="sng" algn="ctr">
+          <a:solidFill>
+            <a:schemeClr val="phClr"/>
+          </a:solidFill>
+          <a:prstDash val="solid"/>
+          <a:miter lim="800000"/>
+        </a:ln>
+        <a:ln w="12700" cap="flat" cmpd="sng" algn="ctr">
+          <a:solidFill>
+            <a:schemeClr val="phClr"/>
+          </a:solidFill>
+          <a:prstDash val="solid"/>
+          <a:miter lim="800000"/>
+        </a:ln>
+        <a:ln w="19050" cap="flat" cmpd="sng" algn="ctr">
+          <a:solidFill>
+            <a:schemeClr val="phClr"/>
+          </a:solidFill>
+          <a:prstDash val="solid"/>
+          <a:miter lim="800000"/>
+        </a:ln>
+      </a:lnStyleLst>
+      <a:effectStyleLst>
+        <a:effectStyle>
+          <a:effectLst/>
+        </a:effectStyle>
+        <a:effectStyle>
+          <a:effectLst/>
+        </a:effectStyle>
+        <a:effectStyle>
+          <a:effectLst>
+            <a:outerShdw blurRad="57150" dist="19050" dir="5400000" algn="ctr" rotWithShape="0">
+              <a:srgbClr val="000000">
+                <a:alpha val="63000"/>
+              </a:srgbClr>
+            </a:outerShdw>
+          </a:effectLst>
+        </a:effectStyle>
+      </a:effectStyleLst>
+      <a:bgFillStyleLst>
+        <a:solidFill>
+          <a:schemeClr val="phClr"/>
+        </a:solidFill>
+        <a:solidFill>
+          <a:schemeClr val="phClr">
+            <a:tint val="95000"/>
+            <a:satMod val="170000"/>
+          </a:schemeClr>
+        </a:solidFill>
+        <a:gradFill rotWithShape="1">
+          <a:gsLst>
+            <a:gs pos="0">
+              <a:schemeClr val="phClr">
+                <a:tint val="93000"/>
+                <a:satMod val="150000"/>
+                <a:shade val="98000"/>
+                <a:lumMod val="102000"/>
+              </a:schemeClr>
+            </a:gs>
+            <a:gs pos="50000">
+              <a:schemeClr val="phClr">
+                <a:tint val="98000"/>
+                <a:satMod val="130000"/>
+                <a:shade val="90000"/>
+                <a:lumMod val="103000"/>
+              </a:schemeClr>
+            </a:gs>
+            <a:gs pos="100000">
+              <a:schemeClr val="phClr">
+                <a:shade val="63000"/>
+                <a:satMod val="120000"/>
+              </a:schemeClr>
+            </a:gs>
+          </a:gsLst>
+          <a:lin ang="5400000" scaled="0"/>
+        </a:gradFill>
+      </a:bgFillStyleLst>
+    </a:fmtScheme>
+  </a:themeElements>
+  <a:objectDefaults/>
+  <a:extraClrSchemeLst/>
+  <a:extLst>
+    <a:ext uri="{05A4C25C-085E-4340-85A3-A5531E510DB2}">
+      <thm15:themeFamily xmlns:thm15="http://schemas.microsoft.com/office/thememl/2012/main" name="Office Theme" id="{62F939B6-93AF-4DB8-9C6B-D6C7DFDC589F}" vid="{4A3C46E8-61CC-4603-A589-7422A47A8E4A}"/>
+    </a:ext>
+  </a:extLst>
+</a:theme>
 </file>
</xml_diff>

<commit_message>
Remove AI declaration slide from deck (declared separately as PDF)
</commit_message>
<xml_diff>
--- a/FIT3143_Lab1_Presentation.pptx
+++ b/FIT3143_Lab1_Presentation.pptx
@@ -5,7 +5,7 @@
     <p:sldMasterId id="2147483648" r:id="rId1"/>
   </p:sldMasterIdLst>
   <p:notesMasterIdLst>
-    <p:notesMasterId r:id="rId16"/>
+    <p:notesMasterId r:id="rId15"/>
   </p:notesMasterIdLst>
   <p:sldIdLst>
     <p:sldId id="256" r:id="rId2"/>
@@ -21,7 +21,6 @@
     <p:sldId id="267" r:id="rId12"/>
     <p:sldId id="268" r:id="rId13"/>
     <p:sldId id="269" r:id="rId14"/>
-    <p:sldId id="270" r:id="rId15"/>
   </p:sldIdLst>
   <p:sldSz cx="12192000" cy="6858000"/>
   <p:notesSz cx="6858000" cy="12192000"/>
@@ -667,93 +666,6 @@
             <a:fld id="{F7021451-1387-4CA6-816F-3879F97B5CBC}" type="slidenum">
               <a:rPr lang="en-US"/>
               <a:t>13</a:t>
-            </a:fld>
-            <a:endParaRPr lang="en-US"/>
-          </a:p>
-        </p:txBody>
-      </p:sp>
-    </p:spTree>
-    <p:extLst>
-      <p:ext uri="{BB962C8B-B14F-4D97-AF65-F5344CB8AC3E}">
-        <p14:creationId xmlns:p14="http://schemas.microsoft.com/office/powerpoint/2010/main" val="1024086991"/>
-      </p:ext>
-    </p:extLst>
-  </p:cSld>
-  <p:clrMapOvr>
-    <a:masterClrMapping/>
-  </p:clrMapOvr>
-</p:notes>
-</file>
-
-<file path=ppt/notesSlides/notesSlide14.xml><?xml version="1.0" encoding="utf-8"?>
-<p:notes xmlns:a="http://schemas.openxmlformats.org/drawingml/2006/main" xmlns:r="http://schemas.openxmlformats.org/officeDocument/2006/relationships" xmlns:p="http://schemas.openxmlformats.org/presentationml/2006/main">
-  <p:cSld>
-    <p:spTree>
-      <p:nvGrpSpPr>
-        <p:cNvPr id="1" name=""/>
-        <p:cNvGrpSpPr/>
-        <p:nvPr/>
-      </p:nvGrpSpPr>
-      <p:grpSpPr>
-        <a:xfrm>
-          <a:off x="0" y="0"/>
-          <a:ext cx="0" cy="0"/>
-          <a:chOff x="0" y="0"/>
-          <a:chExt cx="0" cy="0"/>
-        </a:xfrm>
-      </p:grpSpPr>
-      <p:sp>
-        <p:nvSpPr>
-          <p:cNvPr id="2" name="Slide Image Placeholder 1"/>
-          <p:cNvSpPr>
-            <a:spLocks noGrp="1" noRot="1" noChangeAspect="1"/>
-          </p:cNvSpPr>
-          <p:nvPr>
-            <p:ph type="sldImg"/>
-          </p:nvPr>
-        </p:nvSpPr>
-        <p:spPr/>
-      </p:sp>
-      <p:sp>
-        <p:nvSpPr>
-          <p:cNvPr id="3" name="Notes Placeholder 2"/>
-          <p:cNvSpPr>
-            <a:spLocks noGrp="1"/>
-          </p:cNvSpPr>
-          <p:nvPr>
-            <p:ph type="body" idx="1"/>
-          </p:nvPr>
-        </p:nvSpPr>
-        <p:spPr/>
-        <p:txBody>
-          <a:bodyPr/>
-          <a:lstStyle/>
-          <a:p>
-            <a:r>
-              <a:rPr lang="en-US" dirty="0"/>
-              <a:t>Fill in the brackets before submission.</a:t>
-            </a:r>
-          </a:p>
-        </p:txBody>
-      </p:sp>
-      <p:sp>
-        <p:nvSpPr>
-          <p:cNvPr id="4" name="Slide Number Placeholder 3"/>
-          <p:cNvSpPr>
-            <a:spLocks noGrp="1"/>
-          </p:cNvSpPr>
-          <p:nvPr>
-            <p:ph type="sldNum" sz="quarter" idx="10"/>
-          </p:nvPr>
-        </p:nvSpPr>
-        <p:spPr/>
-        <p:txBody>
-          <a:bodyPr/>
-          <a:lstStyle/>
-          <a:p>
-            <a:fld id="{F7021451-1387-4CA6-816F-3879F97B5CBC}" type="slidenum">
-              <a:rPr lang="en-US"/>
-              <a:t>14</a:t>
             </a:fld>
             <a:endParaRPr lang="en-US"/>
           </a:p>
@@ -1905,6 +1817,13 @@
             <a:prstDash val="solid"/>
           </a:ln>
         </p:spPr>
+        <p:txBody>
+          <a:bodyPr/>
+          <a:lstStyle/>
+          <a:p>
+            <a:endParaRPr lang="en-US"/>
+          </a:p>
+        </p:txBody>
       </p:sp>
       <p:sp>
         <p:nvSpPr>
@@ -1942,7 +1861,7 @@
                 <a:ea typeface="Calibri" pitchFamily="34" charset="-122"/>
                 <a:cs typeface="Calibri" pitchFamily="34" charset="-120"/>
               </a:rPr>
-              <a:t>[Student 1 name]  ·  [ID]  ·  [name@student.monash.edu]</a:t>
+              <a:t>Haruto Iriyama  ·  34307710  ·  hiri0001@student.monash.edu</a:t>
             </a:r>
             <a:endParaRPr lang="en-US" sz="1400" dirty="0"/>
           </a:p>
@@ -1962,18 +1881,7 @@
                 <a:ea typeface="Calibri" pitchFamily="34" charset="-122"/>
                 <a:cs typeface="Calibri" pitchFamily="34" charset="-120"/>
               </a:rPr>
-              <a:t>Hiew Jia Hao ·  34533664  </a:t>
-            </a:r>
-            <a:r>
-              <a:rPr lang="en-US" sz="1400">
-                <a:solidFill>
-                  <a:srgbClr val="C6CDD1"/>
-                </a:solidFill>
-                <a:latin typeface="Calibri" pitchFamily="34" charset="0"/>
-                <a:ea typeface="Calibri" pitchFamily="34" charset="-122"/>
-                <a:cs typeface="Calibri" pitchFamily="34" charset="-120"/>
-              </a:rPr>
-              <a:t>·  jhie0006@student.monash.edu</a:t>
+              <a:t>Hiew Jia Hao ·  34533664  ·  jhie0006@student.monash.edu</a:t>
             </a:r>
             <a:endParaRPr lang="en-US" sz="1400" dirty="0"/>
           </a:p>
@@ -2062,6 +1970,13 @@
           </a:solidFill>
           <a:ln/>
         </p:spPr>
+        <p:txBody>
+          <a:bodyPr/>
+          <a:lstStyle/>
+          <a:p>
+            <a:endParaRPr lang="en-US"/>
+          </a:p>
+        </p:txBody>
       </p:sp>
       <p:sp>
         <p:nvSpPr>
@@ -2358,6 +2273,13 @@
           </a:solidFill>
           <a:ln/>
         </p:spPr>
+        <p:txBody>
+          <a:bodyPr/>
+          <a:lstStyle/>
+          <a:p>
+            <a:endParaRPr lang="en-US"/>
+          </a:p>
+        </p:txBody>
       </p:sp>
       <p:sp>
         <p:nvSpPr>
@@ -2511,6 +2433,13 @@
           </a:solidFill>
           <a:ln/>
         </p:spPr>
+        <p:txBody>
+          <a:bodyPr/>
+          <a:lstStyle/>
+          <a:p>
+            <a:endParaRPr lang="en-US"/>
+          </a:p>
+        </p:txBody>
       </p:sp>
       <p:sp>
         <p:nvSpPr>
@@ -2664,6 +2593,13 @@
           </a:solidFill>
           <a:ln/>
         </p:spPr>
+        <p:txBody>
+          <a:bodyPr/>
+          <a:lstStyle/>
+          <a:p>
+            <a:endParaRPr lang="en-US"/>
+          </a:p>
+        </p:txBody>
       </p:sp>
       <p:sp>
         <p:nvSpPr>
@@ -2992,6 +2928,13 @@
           </a:solidFill>
           <a:ln/>
         </p:spPr>
+        <p:txBody>
+          <a:bodyPr/>
+          <a:lstStyle/>
+          <a:p>
+            <a:endParaRPr lang="en-US"/>
+          </a:p>
+        </p:txBody>
       </p:sp>
       <p:sp>
         <p:nvSpPr>
@@ -3273,376 +3216,6 @@
               <a:t>All three programs share a byte-for-byte identical is_prime, so the comparisons isolate parallelisation</a:t>
             </a:r>
             <a:endParaRPr lang="en-US" sz="1400" dirty="0"/>
-          </a:p>
-        </p:txBody>
-      </p:sp>
-    </p:spTree>
-  </p:cSld>
-  <p:clrMapOvr>
-    <a:masterClrMapping/>
-  </p:clrMapOvr>
-</p:sld>
-</file>
-
-<file path=ppt/slides/slide14.xml><?xml version="1.0" encoding="utf-8"?>
-<p:sld xmlns:a="http://schemas.openxmlformats.org/drawingml/2006/main" xmlns:r="http://schemas.openxmlformats.org/officeDocument/2006/relationships" xmlns:p="http://schemas.openxmlformats.org/presentationml/2006/main">
-  <p:cSld name="Slide 15">
-    <p:spTree>
-      <p:nvGrpSpPr>
-        <p:cNvPr id="1" name=""/>
-        <p:cNvGrpSpPr/>
-        <p:nvPr/>
-      </p:nvGrpSpPr>
-      <p:grpSpPr>
-        <a:xfrm>
-          <a:off x="0" y="0"/>
-          <a:ext cx="0" cy="0"/>
-          <a:chOff x="0" y="0"/>
-          <a:chExt cx="0" cy="0"/>
-        </a:xfrm>
-      </p:grpSpPr>
-      <p:sp>
-        <p:nvSpPr>
-          <p:cNvPr id="2" name="Shape 0"/>
-          <p:cNvSpPr/>
-          <p:nvPr/>
-        </p:nvSpPr>
-        <p:spPr>
-          <a:xfrm>
-            <a:off x="548640" y="384048"/>
-            <a:ext cx="566928" cy="566928"/>
-          </a:xfrm>
-          <a:prstGeom prst="ellipse">
-            <a:avLst/>
-          </a:prstGeom>
-          <a:solidFill>
-            <a:srgbClr val="EB6834"/>
-          </a:solidFill>
-          <a:ln/>
-        </p:spPr>
-      </p:sp>
-      <p:sp>
-        <p:nvSpPr>
-          <p:cNvPr id="3" name="Text 1"/>
-          <p:cNvSpPr/>
-          <p:nvPr/>
-        </p:nvSpPr>
-        <p:spPr>
-          <a:xfrm>
-            <a:off x="548640" y="384048"/>
-            <a:ext cx="566928" cy="566928"/>
-          </a:xfrm>
-          <a:prstGeom prst="rect">
-            <a:avLst/>
-          </a:prstGeom>
-          <a:noFill/>
-          <a:ln/>
-        </p:spPr>
-        <p:txBody>
-          <a:bodyPr wrap="square" lIns="0" tIns="0" rIns="0" bIns="0" rtlCol="0" anchor="ctr"/>
-          <a:lstStyle/>
-          <a:p>
-            <a:pPr marL="0" indent="0" algn="ctr">
-              <a:buNone/>
-            </a:pPr>
-            <a:r>
-              <a:rPr lang="en-US" sz="2200" b="1" dirty="0">
-                <a:solidFill>
-                  <a:srgbClr val="FFFFFF"/>
-                </a:solidFill>
-                <a:latin typeface="Calibri" pitchFamily="34" charset="0"/>
-                <a:ea typeface="Calibri" pitchFamily="34" charset="-122"/>
-                <a:cs typeface="Calibri" pitchFamily="34" charset="-120"/>
-              </a:rPr>
-              <a:t>A</a:t>
-            </a:r>
-            <a:endParaRPr lang="en-US" sz="2200" dirty="0"/>
-          </a:p>
-        </p:txBody>
-      </p:sp>
-      <p:sp>
-        <p:nvSpPr>
-          <p:cNvPr id="4" name="Text 2"/>
-          <p:cNvSpPr/>
-          <p:nvPr/>
-        </p:nvSpPr>
-        <p:spPr>
-          <a:xfrm>
-            <a:off x="1325880" y="347472"/>
-            <a:ext cx="10287000" cy="457200"/>
-          </a:xfrm>
-          <a:prstGeom prst="rect">
-            <a:avLst/>
-          </a:prstGeom>
-          <a:noFill/>
-          <a:ln/>
-        </p:spPr>
-        <p:txBody>
-          <a:bodyPr wrap="square" lIns="0" tIns="0" rIns="0" bIns="0" rtlCol="0" anchor="ctr"/>
-          <a:lstStyle/>
-          <a:p>
-            <a:pPr marL="0" indent="0">
-              <a:buNone/>
-            </a:pPr>
-            <a:r>
-              <a:rPr lang="en-US" sz="3000" b="1" dirty="0">
-                <a:solidFill>
-                  <a:srgbClr val="1A2226"/>
-                </a:solidFill>
-                <a:latin typeface="Calibri" pitchFamily="34" charset="0"/>
-                <a:ea typeface="Calibri" pitchFamily="34" charset="-122"/>
-                <a:cs typeface="Calibri" pitchFamily="34" charset="-120"/>
-              </a:rPr>
-              <a:t>Appendix — declaration of AI use</a:t>
-            </a:r>
-            <a:endParaRPr lang="en-US" sz="3000" dirty="0"/>
-          </a:p>
-        </p:txBody>
-      </p:sp>
-      <p:sp>
-        <p:nvSpPr>
-          <p:cNvPr id="5" name="Text 3"/>
-          <p:cNvSpPr/>
-          <p:nvPr/>
-        </p:nvSpPr>
-        <p:spPr>
-          <a:xfrm>
-            <a:off x="1325880" y="804672"/>
-            <a:ext cx="10287000" cy="310896"/>
-          </a:xfrm>
-          <a:prstGeom prst="rect">
-            <a:avLst/>
-          </a:prstGeom>
-          <a:noFill/>
-          <a:ln/>
-        </p:spPr>
-        <p:txBody>
-          <a:bodyPr wrap="square" lIns="0" tIns="0" rIns="0" bIns="0" rtlCol="0" anchor="ctr"/>
-          <a:lstStyle/>
-          <a:p>
-            <a:pPr marL="0" indent="0">
-              <a:buNone/>
-            </a:pPr>
-            <a:r>
-              <a:rPr lang="en-US" sz="1300" dirty="0">
-                <a:solidFill>
-                  <a:srgbClr val="52616B"/>
-                </a:solidFill>
-                <a:latin typeface="Calibri" pitchFamily="34" charset="0"/>
-                <a:ea typeface="Calibri" pitchFamily="34" charset="-122"/>
-                <a:cs typeface="Calibri" pitchFamily="34" charset="-120"/>
-              </a:rPr>
-              <a:t>Required by the assessment specification</a:t>
-            </a:r>
-            <a:endParaRPr lang="en-US" sz="1300" dirty="0"/>
-          </a:p>
-        </p:txBody>
-      </p:sp>
-      <p:sp>
-        <p:nvSpPr>
-          <p:cNvPr id="6" name="Text 4"/>
-          <p:cNvSpPr/>
-          <p:nvPr/>
-        </p:nvSpPr>
-        <p:spPr>
-          <a:xfrm>
-            <a:off x="548640" y="1417320"/>
-            <a:ext cx="11064240" cy="3931920"/>
-          </a:xfrm>
-          <a:prstGeom prst="rect">
-            <a:avLst/>
-          </a:prstGeom>
-          <a:noFill/>
-          <a:ln/>
-        </p:spPr>
-        <p:txBody>
-          <a:bodyPr wrap="square" lIns="0" tIns="0" rIns="0" bIns="0" rtlCol="0" anchor="ctr"/>
-          <a:lstStyle/>
-          <a:p>
-            <a:pPr marL="342900" indent="-342900">
-              <a:lnSpc>
-                <a:spcPts val="2200"/>
-              </a:lnSpc>
-              <a:spcAft>
-                <a:spcPts val="800"/>
-              </a:spcAft>
-              <a:buSzPct val="100000"/>
-              <a:buChar char="•"/>
-            </a:pPr>
-            <a:r>
-              <a:rPr lang="en-US" sz="1400" dirty="0">
-                <a:solidFill>
-                  <a:srgbClr val="52616B"/>
-                </a:solidFill>
-                <a:latin typeface="Calibri" pitchFamily="34" charset="0"/>
-                <a:ea typeface="Calibri" pitchFamily="34" charset="-122"/>
-                <a:cs typeface="Calibri" pitchFamily="34" charset="-120"/>
-              </a:rPr>
-              <a:t>Generative AI was used during the preparation period only. It was not used during the presentation or the Q&amp;A session.</a:t>
-            </a:r>
-            <a:endParaRPr lang="en-US" sz="1400" dirty="0"/>
-          </a:p>
-          <a:p>
-            <a:pPr marL="342900" indent="-342900">
-              <a:lnSpc>
-                <a:spcPts val="2200"/>
-              </a:lnSpc>
-              <a:spcAft>
-                <a:spcPts val="800"/>
-              </a:spcAft>
-              <a:buSzPct val="100000"/>
-              <a:buChar char="•"/>
-            </a:pPr>
-            <a:r>
-              <a:rPr lang="en-US" sz="1400" dirty="0">
-                <a:solidFill>
-                  <a:srgbClr val="52616B"/>
-                </a:solidFill>
-                <a:latin typeface="Calibri" pitchFamily="34" charset="0"/>
-                <a:ea typeface="Calibri" pitchFamily="34" charset="-122"/>
-                <a:cs typeface="Calibri" pitchFamily="34" charset="-120"/>
-              </a:rPr>
-              <a:t>[Describe what it was used for — for example: reviewing the partitioning scheme, drafting the benchmark and plotting scripts, and checking the interpretation of the measurements.]</a:t>
-            </a:r>
-            <a:endParaRPr lang="en-US" sz="1400" dirty="0"/>
-          </a:p>
-          <a:p>
-            <a:pPr marL="342900" indent="-342900">
-              <a:lnSpc>
-                <a:spcPts val="2200"/>
-              </a:lnSpc>
-              <a:spcAft>
-                <a:spcPts val="800"/>
-              </a:spcAft>
-              <a:buSzPct val="100000"/>
-              <a:buChar char="•"/>
-            </a:pPr>
-            <a:r>
-              <a:rPr lang="en-US" sz="1400" dirty="0">
-                <a:solidFill>
-                  <a:srgbClr val="52616B"/>
-                </a:solidFill>
-                <a:latin typeface="Calibri" pitchFamily="34" charset="0"/>
-                <a:ea typeface="Calibri" pitchFamily="34" charset="-122"/>
-                <a:cs typeface="Calibri" pitchFamily="34" charset="-120"/>
-              </a:rPr>
-              <a:t>[State which tool and which version.]</a:t>
-            </a:r>
-            <a:endParaRPr lang="en-US" sz="1400" dirty="0"/>
-          </a:p>
-          <a:p>
-            <a:pPr marL="342900" indent="-342900">
-              <a:lnSpc>
-                <a:spcPts val="2200"/>
-              </a:lnSpc>
-              <a:spcAft>
-                <a:spcPts val="800"/>
-              </a:spcAft>
-              <a:buSzPct val="100000"/>
-              <a:buChar char="•"/>
-            </a:pPr>
-            <a:r>
-              <a:rPr lang="en-US" sz="1400" dirty="0">
-                <a:solidFill>
-                  <a:srgbClr val="52616B"/>
-                </a:solidFill>
-                <a:latin typeface="Calibri" pitchFamily="34" charset="0"/>
-                <a:ea typeface="Calibri" pitchFamily="34" charset="-122"/>
-                <a:cs typeface="Calibri" pitchFamily="34" charset="-120"/>
-              </a:rPr>
-              <a:t>All measurements reported in these slides were produced by running our own code on our own machine. Every number is reproducible from the repository.</a:t>
-            </a:r>
-            <a:endParaRPr lang="en-US" sz="1400" dirty="0"/>
-          </a:p>
-          <a:p>
-            <a:pPr marL="342900" indent="-342900">
-              <a:lnSpc>
-                <a:spcPts val="2200"/>
-              </a:lnSpc>
-              <a:spcAft>
-                <a:spcPts val="800"/>
-              </a:spcAft>
-              <a:buSzPct val="100000"/>
-              <a:buChar char="•"/>
-            </a:pPr>
-            <a:r>
-              <a:rPr lang="en-US" sz="1400" dirty="0">
-                <a:solidFill>
-                  <a:srgbClr val="52616B"/>
-                </a:solidFill>
-                <a:latin typeface="Calibri" pitchFamily="34" charset="0"/>
-                <a:ea typeface="Calibri" pitchFamily="34" charset="-122"/>
-                <a:cs typeface="Calibri" pitchFamily="34" charset="-120"/>
-              </a:rPr>
-              <a:t>The full prompt records are submitted separately as a PDF, as required by the specification.</a:t>
-            </a:r>
-            <a:endParaRPr lang="en-US" sz="1400" dirty="0"/>
-          </a:p>
-        </p:txBody>
-      </p:sp>
-      <p:sp>
-        <p:nvSpPr>
-          <p:cNvPr id="7" name="Shape 5"/>
-          <p:cNvSpPr/>
-          <p:nvPr/>
-        </p:nvSpPr>
-        <p:spPr>
-          <a:xfrm>
-            <a:off x="548640" y="5212080"/>
-            <a:ext cx="11064240" cy="621792"/>
-          </a:xfrm>
-          <a:prstGeom prst="roundRect">
-            <a:avLst>
-              <a:gd name="adj" fmla="val 8824"/>
-            </a:avLst>
-          </a:prstGeom>
-          <a:solidFill>
-            <a:srgbClr val="FDF0EA"/>
-          </a:solidFill>
-          <a:ln w="12700">
-            <a:solidFill>
-              <a:srgbClr val="FDF0EA"/>
-            </a:solidFill>
-            <a:prstDash val="solid"/>
-          </a:ln>
-        </p:spPr>
-      </p:sp>
-      <p:sp>
-        <p:nvSpPr>
-          <p:cNvPr id="8" name="Text 6"/>
-          <p:cNvSpPr/>
-          <p:nvPr/>
-        </p:nvSpPr>
-        <p:spPr>
-          <a:xfrm>
-            <a:off x="731520" y="5321808"/>
-            <a:ext cx="10698480" cy="402336"/>
-          </a:xfrm>
-          <a:prstGeom prst="rect">
-            <a:avLst/>
-          </a:prstGeom>
-          <a:noFill/>
-          <a:ln/>
-        </p:spPr>
-        <p:txBody>
-          <a:bodyPr wrap="square" lIns="0" tIns="0" rIns="0" bIns="0" rtlCol="0" anchor="ctr"/>
-          <a:lstStyle/>
-          <a:p>
-            <a:pPr marL="0" indent="0">
-              <a:buNone/>
-            </a:pPr>
-            <a:r>
-              <a:rPr lang="en-US" sz="1250" b="1" dirty="0">
-                <a:solidFill>
-                  <a:srgbClr val="8A3B1C"/>
-                </a:solidFill>
-                <a:latin typeface="Calibri" pitchFamily="34" charset="0"/>
-                <a:ea typeface="Calibri" pitchFamily="34" charset="-122"/>
-                <a:cs typeface="Calibri" pitchFamily="34" charset="-120"/>
-              </a:rPr>
-              <a:t>Complete the bracketed items before submitting, and attach the prompt-record PDF.</a:t>
-            </a:r>
-            <a:endParaRPr lang="en-US" sz="1250" dirty="0"/>
           </a:p>
         </p:txBody>
       </p:sp>
@@ -3690,6 +3263,13 @@
           </a:solidFill>
           <a:ln/>
         </p:spPr>
+        <p:txBody>
+          <a:bodyPr/>
+          <a:lstStyle/>
+          <a:p>
+            <a:endParaRPr lang="en-US"/>
+          </a:p>
+        </p:txBody>
       </p:sp>
       <p:sp>
         <p:nvSpPr>
@@ -3952,6 +3532,13 @@
             <a:prstDash val="solid"/>
           </a:ln>
         </p:spPr>
+        <p:txBody>
+          <a:bodyPr/>
+          <a:lstStyle/>
+          <a:p>
+            <a:endParaRPr lang="en-US"/>
+          </a:p>
+        </p:txBody>
       </p:sp>
       <p:sp>
         <p:nvSpPr>
@@ -4238,6 +3825,13 @@
           </a:solidFill>
           <a:ln/>
         </p:spPr>
+        <p:txBody>
+          <a:bodyPr/>
+          <a:lstStyle/>
+          <a:p>
+            <a:endParaRPr lang="en-US"/>
+          </a:p>
+        </p:txBody>
       </p:sp>
       <p:sp>
         <p:nvSpPr>
@@ -4406,6 +4000,13 @@
             <a:prstDash val="solid"/>
           </a:ln>
         </p:spPr>
+        <p:txBody>
+          <a:bodyPr/>
+          <a:lstStyle/>
+          <a:p>
+            <a:endParaRPr lang="en-US"/>
+          </a:p>
+        </p:txBody>
       </p:sp>
       <p:sp>
         <p:nvSpPr>
@@ -4511,6 +4112,13 @@
             <a:prstDash val="solid"/>
           </a:ln>
         </p:spPr>
+        <p:txBody>
+          <a:bodyPr/>
+          <a:lstStyle/>
+          <a:p>
+            <a:endParaRPr lang="en-US"/>
+          </a:p>
+        </p:txBody>
       </p:sp>
       <p:sp>
         <p:nvSpPr>
@@ -4686,6 +4294,13 @@
             <a:prstDash val="solid"/>
           </a:ln>
         </p:spPr>
+        <p:txBody>
+          <a:bodyPr/>
+          <a:lstStyle/>
+          <a:p>
+            <a:endParaRPr lang="en-US"/>
+          </a:p>
+        </p:txBody>
       </p:sp>
       <p:sp>
         <p:nvSpPr>
@@ -4770,6 +4385,13 @@
           </a:solidFill>
           <a:ln/>
         </p:spPr>
+        <p:txBody>
+          <a:bodyPr/>
+          <a:lstStyle/>
+          <a:p>
+            <a:endParaRPr lang="en-US"/>
+          </a:p>
+        </p:txBody>
       </p:sp>
       <p:sp>
         <p:nvSpPr>
@@ -4951,6 +4573,13 @@
             <a:prstDash val="solid"/>
           </a:ln>
         </p:spPr>
+        <p:txBody>
+          <a:bodyPr/>
+          <a:lstStyle/>
+          <a:p>
+            <a:endParaRPr lang="en-US"/>
+          </a:p>
+        </p:txBody>
       </p:sp>
       <p:sp>
         <p:nvSpPr>
@@ -4976,6 +4605,13 @@
             <a:prstDash val="solid"/>
           </a:ln>
         </p:spPr>
+        <p:txBody>
+          <a:bodyPr/>
+          <a:lstStyle/>
+          <a:p>
+            <a:endParaRPr lang="en-US"/>
+          </a:p>
+        </p:txBody>
       </p:sp>
       <p:sp>
         <p:nvSpPr>
@@ -5001,6 +4637,13 @@
             <a:prstDash val="solid"/>
           </a:ln>
         </p:spPr>
+        <p:txBody>
+          <a:bodyPr/>
+          <a:lstStyle/>
+          <a:p>
+            <a:endParaRPr lang="en-US"/>
+          </a:p>
+        </p:txBody>
       </p:sp>
       <p:sp>
         <p:nvSpPr>
@@ -5026,6 +4669,13 @@
             <a:prstDash val="solid"/>
           </a:ln>
         </p:spPr>
+        <p:txBody>
+          <a:bodyPr/>
+          <a:lstStyle/>
+          <a:p>
+            <a:endParaRPr lang="en-US"/>
+          </a:p>
+        </p:txBody>
       </p:sp>
       <p:sp>
         <p:nvSpPr>
@@ -5051,6 +4701,13 @@
             <a:prstDash val="solid"/>
           </a:ln>
         </p:spPr>
+        <p:txBody>
+          <a:bodyPr/>
+          <a:lstStyle/>
+          <a:p>
+            <a:endParaRPr lang="en-US"/>
+          </a:p>
+        </p:txBody>
       </p:sp>
       <p:sp>
         <p:nvSpPr>
@@ -5076,6 +4733,13 @@
             <a:prstDash val="solid"/>
           </a:ln>
         </p:spPr>
+        <p:txBody>
+          <a:bodyPr/>
+          <a:lstStyle/>
+          <a:p>
+            <a:endParaRPr lang="en-US"/>
+          </a:p>
+        </p:txBody>
       </p:sp>
       <p:sp>
         <p:nvSpPr>
@@ -5101,6 +4765,13 @@
             <a:prstDash val="solid"/>
           </a:ln>
         </p:spPr>
+        <p:txBody>
+          <a:bodyPr/>
+          <a:lstStyle/>
+          <a:p>
+            <a:endParaRPr lang="en-US"/>
+          </a:p>
+        </p:txBody>
       </p:sp>
       <p:sp>
         <p:nvSpPr>
@@ -5126,6 +4797,13 @@
             <a:prstDash val="solid"/>
           </a:ln>
         </p:spPr>
+        <p:txBody>
+          <a:bodyPr/>
+          <a:lstStyle/>
+          <a:p>
+            <a:endParaRPr lang="en-US"/>
+          </a:p>
+        </p:txBody>
       </p:sp>
       <p:sp>
         <p:nvSpPr>
@@ -5151,6 +4829,13 @@
             <a:prstDash val="solid"/>
           </a:ln>
         </p:spPr>
+        <p:txBody>
+          <a:bodyPr/>
+          <a:lstStyle/>
+          <a:p>
+            <a:endParaRPr lang="en-US"/>
+          </a:p>
+        </p:txBody>
       </p:sp>
       <p:sp>
         <p:nvSpPr>
@@ -5176,6 +4861,13 @@
             <a:prstDash val="solid"/>
           </a:ln>
         </p:spPr>
+        <p:txBody>
+          <a:bodyPr/>
+          <a:lstStyle/>
+          <a:p>
+            <a:endParaRPr lang="en-US"/>
+          </a:p>
+        </p:txBody>
       </p:sp>
       <p:sp>
         <p:nvSpPr>
@@ -5201,6 +4893,13 @@
             <a:prstDash val="solid"/>
           </a:ln>
         </p:spPr>
+        <p:txBody>
+          <a:bodyPr/>
+          <a:lstStyle/>
+          <a:p>
+            <a:endParaRPr lang="en-US"/>
+          </a:p>
+        </p:txBody>
       </p:sp>
       <p:sp>
         <p:nvSpPr>
@@ -5226,6 +4925,13 @@
             <a:prstDash val="solid"/>
           </a:ln>
         </p:spPr>
+        <p:txBody>
+          <a:bodyPr/>
+          <a:lstStyle/>
+          <a:p>
+            <a:endParaRPr lang="en-US"/>
+          </a:p>
+        </p:txBody>
       </p:sp>
       <p:sp>
         <p:nvSpPr>
@@ -5251,6 +4957,13 @@
             <a:prstDash val="solid"/>
           </a:ln>
         </p:spPr>
+        <p:txBody>
+          <a:bodyPr/>
+          <a:lstStyle/>
+          <a:p>
+            <a:endParaRPr lang="en-US"/>
+          </a:p>
+        </p:txBody>
       </p:sp>
       <p:sp>
         <p:nvSpPr>
@@ -5276,6 +4989,13 @@
             <a:prstDash val="solid"/>
           </a:ln>
         </p:spPr>
+        <p:txBody>
+          <a:bodyPr/>
+          <a:lstStyle/>
+          <a:p>
+            <a:endParaRPr lang="en-US"/>
+          </a:p>
+        </p:txBody>
       </p:sp>
       <p:sp>
         <p:nvSpPr>
@@ -5301,6 +5021,13 @@
             <a:prstDash val="solid"/>
           </a:ln>
         </p:spPr>
+        <p:txBody>
+          <a:bodyPr/>
+          <a:lstStyle/>
+          <a:p>
+            <a:endParaRPr lang="en-US"/>
+          </a:p>
+        </p:txBody>
       </p:sp>
       <p:sp>
         <p:nvSpPr>
@@ -5326,6 +5053,13 @@
             <a:prstDash val="solid"/>
           </a:ln>
         </p:spPr>
+        <p:txBody>
+          <a:bodyPr/>
+          <a:lstStyle/>
+          <a:p>
+            <a:endParaRPr lang="en-US"/>
+          </a:p>
+        </p:txBody>
       </p:sp>
       <p:sp>
         <p:nvSpPr>
@@ -5429,6 +5163,13 @@
             <a:prstDash val="solid"/>
           </a:ln>
         </p:spPr>
+        <p:txBody>
+          <a:bodyPr/>
+          <a:lstStyle/>
+          <a:p>
+            <a:endParaRPr lang="en-US"/>
+          </a:p>
+        </p:txBody>
       </p:sp>
       <p:sp>
         <p:nvSpPr>
@@ -5454,6 +5195,13 @@
             <a:prstDash val="solid"/>
           </a:ln>
         </p:spPr>
+        <p:txBody>
+          <a:bodyPr/>
+          <a:lstStyle/>
+          <a:p>
+            <a:endParaRPr lang="en-US"/>
+          </a:p>
+        </p:txBody>
       </p:sp>
       <p:sp>
         <p:nvSpPr>
@@ -5479,6 +5227,13 @@
             <a:prstDash val="solid"/>
           </a:ln>
         </p:spPr>
+        <p:txBody>
+          <a:bodyPr/>
+          <a:lstStyle/>
+          <a:p>
+            <a:endParaRPr lang="en-US"/>
+          </a:p>
+        </p:txBody>
       </p:sp>
       <p:sp>
         <p:nvSpPr>
@@ -5504,6 +5259,13 @@
             <a:prstDash val="solid"/>
           </a:ln>
         </p:spPr>
+        <p:txBody>
+          <a:bodyPr/>
+          <a:lstStyle/>
+          <a:p>
+            <a:endParaRPr lang="en-US"/>
+          </a:p>
+        </p:txBody>
       </p:sp>
       <p:sp>
         <p:nvSpPr>
@@ -5529,6 +5291,13 @@
             <a:prstDash val="solid"/>
           </a:ln>
         </p:spPr>
+        <p:txBody>
+          <a:bodyPr/>
+          <a:lstStyle/>
+          <a:p>
+            <a:endParaRPr lang="en-US"/>
+          </a:p>
+        </p:txBody>
       </p:sp>
       <p:sp>
         <p:nvSpPr>
@@ -5554,6 +5323,13 @@
             <a:prstDash val="solid"/>
           </a:ln>
         </p:spPr>
+        <p:txBody>
+          <a:bodyPr/>
+          <a:lstStyle/>
+          <a:p>
+            <a:endParaRPr lang="en-US"/>
+          </a:p>
+        </p:txBody>
       </p:sp>
       <p:sp>
         <p:nvSpPr>
@@ -5579,6 +5355,13 @@
             <a:prstDash val="solid"/>
           </a:ln>
         </p:spPr>
+        <p:txBody>
+          <a:bodyPr/>
+          <a:lstStyle/>
+          <a:p>
+            <a:endParaRPr lang="en-US"/>
+          </a:p>
+        </p:txBody>
       </p:sp>
       <p:sp>
         <p:nvSpPr>
@@ -5604,6 +5387,13 @@
             <a:prstDash val="solid"/>
           </a:ln>
         </p:spPr>
+        <p:txBody>
+          <a:bodyPr/>
+          <a:lstStyle/>
+          <a:p>
+            <a:endParaRPr lang="en-US"/>
+          </a:p>
+        </p:txBody>
       </p:sp>
       <p:sp>
         <p:nvSpPr>
@@ -5629,6 +5419,13 @@
             <a:prstDash val="solid"/>
           </a:ln>
         </p:spPr>
+        <p:txBody>
+          <a:bodyPr/>
+          <a:lstStyle/>
+          <a:p>
+            <a:endParaRPr lang="en-US"/>
+          </a:p>
+        </p:txBody>
       </p:sp>
       <p:sp>
         <p:nvSpPr>
@@ -5654,6 +5451,13 @@
             <a:prstDash val="solid"/>
           </a:ln>
         </p:spPr>
+        <p:txBody>
+          <a:bodyPr/>
+          <a:lstStyle/>
+          <a:p>
+            <a:endParaRPr lang="en-US"/>
+          </a:p>
+        </p:txBody>
       </p:sp>
       <p:sp>
         <p:nvSpPr>
@@ -5679,6 +5483,13 @@
             <a:prstDash val="solid"/>
           </a:ln>
         </p:spPr>
+        <p:txBody>
+          <a:bodyPr/>
+          <a:lstStyle/>
+          <a:p>
+            <a:endParaRPr lang="en-US"/>
+          </a:p>
+        </p:txBody>
       </p:sp>
       <p:sp>
         <p:nvSpPr>
@@ -5704,6 +5515,13 @@
             <a:prstDash val="solid"/>
           </a:ln>
         </p:spPr>
+        <p:txBody>
+          <a:bodyPr/>
+          <a:lstStyle/>
+          <a:p>
+            <a:endParaRPr lang="en-US"/>
+          </a:p>
+        </p:txBody>
       </p:sp>
       <p:sp>
         <p:nvSpPr>
@@ -5729,6 +5547,13 @@
             <a:prstDash val="solid"/>
           </a:ln>
         </p:spPr>
+        <p:txBody>
+          <a:bodyPr/>
+          <a:lstStyle/>
+          <a:p>
+            <a:endParaRPr lang="en-US"/>
+          </a:p>
+        </p:txBody>
       </p:sp>
       <p:sp>
         <p:nvSpPr>
@@ -5754,6 +5579,13 @@
             <a:prstDash val="solid"/>
           </a:ln>
         </p:spPr>
+        <p:txBody>
+          <a:bodyPr/>
+          <a:lstStyle/>
+          <a:p>
+            <a:endParaRPr lang="en-US"/>
+          </a:p>
+        </p:txBody>
       </p:sp>
       <p:sp>
         <p:nvSpPr>
@@ -5779,6 +5611,13 @@
             <a:prstDash val="solid"/>
           </a:ln>
         </p:spPr>
+        <p:txBody>
+          <a:bodyPr/>
+          <a:lstStyle/>
+          <a:p>
+            <a:endParaRPr lang="en-US"/>
+          </a:p>
+        </p:txBody>
       </p:sp>
       <p:sp>
         <p:nvSpPr>
@@ -5804,6 +5643,13 @@
             <a:prstDash val="solid"/>
           </a:ln>
         </p:spPr>
+        <p:txBody>
+          <a:bodyPr/>
+          <a:lstStyle/>
+          <a:p>
+            <a:endParaRPr lang="en-US"/>
+          </a:p>
+        </p:txBody>
       </p:sp>
       <p:sp>
         <p:nvSpPr>
@@ -5867,6 +5713,13 @@
             <a:tailEnd type="triangle"/>
           </a:ln>
         </p:spPr>
+        <p:txBody>
+          <a:bodyPr/>
+          <a:lstStyle/>
+          <a:p>
+            <a:endParaRPr lang="en-US"/>
+          </a:p>
+        </p:txBody>
       </p:sp>
       <p:sp>
         <p:nvSpPr>
@@ -6108,6 +5961,13 @@
           </a:solidFill>
           <a:ln/>
         </p:spPr>
+        <p:txBody>
+          <a:bodyPr/>
+          <a:lstStyle/>
+          <a:p>
+            <a:endParaRPr lang="en-US"/>
+          </a:p>
+        </p:txBody>
       </p:sp>
       <p:sp>
         <p:nvSpPr>
@@ -6357,6 +6217,13 @@
           </a:solidFill>
           <a:ln/>
         </p:spPr>
+        <p:txBody>
+          <a:bodyPr/>
+          <a:lstStyle/>
+          <a:p>
+            <a:endParaRPr lang="en-US"/>
+          </a:p>
+        </p:txBody>
       </p:sp>
       <p:sp>
         <p:nvSpPr>
@@ -6626,6 +6493,13 @@
           </a:solidFill>
           <a:ln/>
         </p:spPr>
+        <p:txBody>
+          <a:bodyPr/>
+          <a:lstStyle/>
+          <a:p>
+            <a:endParaRPr lang="en-US"/>
+          </a:p>
+        </p:txBody>
       </p:sp>
       <p:sp>
         <p:nvSpPr>
@@ -8417,6 +8291,13 @@
             <a:prstDash val="solid"/>
           </a:ln>
         </p:spPr>
+        <p:txBody>
+          <a:bodyPr/>
+          <a:lstStyle/>
+          <a:p>
+            <a:endParaRPr lang="en-US"/>
+          </a:p>
+        </p:txBody>
       </p:sp>
       <p:sp>
         <p:nvSpPr>
@@ -8540,6 +8421,13 @@
           </a:solidFill>
           <a:ln/>
         </p:spPr>
+        <p:txBody>
+          <a:bodyPr/>
+          <a:lstStyle/>
+          <a:p>
+            <a:endParaRPr lang="en-US"/>
+          </a:p>
+        </p:txBody>
       </p:sp>
       <p:sp>
         <p:nvSpPr>
@@ -8684,6 +8572,13 @@
             <a:prstDash val="solid"/>
           </a:ln>
         </p:spPr>
+        <p:txBody>
+          <a:bodyPr/>
+          <a:lstStyle/>
+          <a:p>
+            <a:endParaRPr lang="en-US"/>
+          </a:p>
+        </p:txBody>
       </p:sp>
       <p:sp>
         <p:nvSpPr>
@@ -10083,6 +9978,13 @@
           </a:solidFill>
           <a:ln/>
         </p:spPr>
+        <p:txBody>
+          <a:bodyPr/>
+          <a:lstStyle/>
+          <a:p>
+            <a:endParaRPr lang="en-US"/>
+          </a:p>
+        </p:txBody>
       </p:sp>
       <p:sp>
         <p:nvSpPr>

</xml_diff>